<commit_message>
Präsentation auf 10 Folien erweitert (mehr Features, Zahlen, Feature-Sammlung)
Drei neue Folien:
- Folie 7 „Mehr Funktionen": VLAN-Suche, Rollen/AD-Verwaltung mit Quellen-Filter,
  eingebaute REST-API (je Screenshot + Kurztext) plus „Außerdem"-Zeile.
- Folie 8 „Das Projekt in Zahlen": 105 Releases · 167 Commits · 11.114 Zeilen
  in 1 Datei · 0 Fremd-Abhängigkeiten · 94 Smoke-Checks · 5 CI-Scanner ·
  620+ Übersetzungen · 11 Verwaltungs-Bereiche.
- Folie 10 „Feature-Highlights" (letzte Folie): sechs gruppierte Boxen mit der
  kompletten Feature-Sammlung.

Fazit-Folie bleibt (jetzt Folie 9). build_deck.py + 3 zusätzliche Screenshots
ergänzt, README auf 10 Folien aktualisiert.

Co-Authored-By: Claude Opus 4.8 <noreply@anthropic.com>
</commit_message>
<xml_diff>
--- a/docs/praesentation/VMware-Kapazitaetsplanung.pptx
+++ b/docs/praesentation/VMware-Kapazitaetsplanung.pptx
@@ -12,6 +12,9 @@
     <p:sldId id="260" r:id="rId11"/>
     <p:sldId id="261" r:id="rId12"/>
     <p:sldId id="262" r:id="rId13"/>
+    <p:sldId id="263" r:id="rId14"/>
+    <p:sldId id="264" r:id="rId15"/>
+    <p:sldId id="265" r:id="rId16"/>
   </p:sldIdLst>
   <p:sldSz cx="12191695" cy="6858000" type="screen4x3"/>
   <p:notesSz cx="6858000" cy="9144000"/>
@@ -3444,8 +3447,8 @@
         </p:nvSpPr>
         <p:spPr>
           <a:xfrm>
-            <a:off x="10698480" y="6419088"/>
-            <a:ext cx="1371600" cy="274320"/>
+            <a:off x="10515600" y="6419088"/>
+            <a:ext cx="1554480" cy="274320"/>
           </a:xfrm>
           <a:prstGeom prst="rect">
             <a:avLst/>
@@ -3476,7 +3479,7 @@
                 </a:solidFill>
                 <a:latin typeface="Segoe UI"/>
               </a:rPr>
-              <a:t>1 / 7</a:t>
+              <a:t>1 / 10</a:t>
             </a:r>
           </a:p>
         </p:txBody>
@@ -3484,6 +3487,1684 @@
       <p:sp>
         <p:nvSpPr>
           <p:cNvPr id="10" name="TextBox 9"/>
+          <p:cNvSpPr txBox="1"/>
+          <p:nvPr/>
+        </p:nvSpPr>
+        <p:spPr>
+          <a:xfrm>
+            <a:off x="502920" y="6419088"/>
+            <a:ext cx="7315200" cy="274320"/>
+          </a:xfrm>
+          <a:prstGeom prst="rect">
+            <a:avLst/>
+          </a:prstGeom>
+          <a:noFill/>
+        </p:spPr>
+        <p:txBody>
+          <a:bodyPr wrap="square" anchor="t" lIns="0" rIns="0" tIns="0" bIns="0">
+            <a:spAutoFit/>
+          </a:bodyPr>
+          <a:lstStyle/>
+          <a:p>
+            <a:pPr algn="l">
+              <a:lnSpc>
+                <a:spcPct val="100000"/>
+              </a:lnSpc>
+              <a:spcBef>
+                <a:spcPts val="0"/>
+              </a:spcBef>
+              <a:spcAft>
+                <a:spcPts val="600"/>
+              </a:spcAft>
+            </a:pPr>
+            <a:r>
+              <a:rPr sz="1000" b="0">
+                <a:solidFill>
+                  <a:srgbClr val="93A0B5"/>
+                </a:solidFill>
+                <a:latin typeface="Segoe UI"/>
+              </a:rPr>
+              <a:t>VMware Kapazitätsplanung</a:t>
+            </a:r>
+          </a:p>
+        </p:txBody>
+      </p:sp>
+    </p:spTree>
+  </p:cSld>
+  <p:clrMapOvr>
+    <a:masterClrMapping/>
+  </p:clrMapOvr>
+</p:sld>
+</file>
+
+<file path=ppt/slides/slide10.xml><?xml version="1.0" encoding="utf-8"?>
+<p:sld xmlns:a="http://schemas.openxmlformats.org/drawingml/2006/main" xmlns:p="http://schemas.openxmlformats.org/presentationml/2006/main" xmlns:r="http://schemas.openxmlformats.org/officeDocument/2006/relationships">
+  <p:cSld>
+    <p:bg>
+      <p:bgPr>
+        <a:solidFill>
+          <a:srgbClr val="0B1220"/>
+        </a:solidFill>
+        <a:effectLst/>
+      </p:bgPr>
+    </p:bg>
+    <p:spTree>
+      <p:nvGrpSpPr>
+        <p:cNvPr id="1" name=""/>
+        <p:cNvGrpSpPr/>
+        <p:nvPr/>
+      </p:nvGrpSpPr>
+      <p:grpSpPr/>
+      <p:sp>
+        <p:nvSpPr>
+          <p:cNvPr id="2" name="TextBox 1"/>
+          <p:cNvSpPr txBox="1"/>
+          <p:nvPr/>
+        </p:nvSpPr>
+        <p:spPr>
+          <a:xfrm>
+            <a:off x="548640" y="640080"/>
+            <a:ext cx="10972800" cy="365760"/>
+          </a:xfrm>
+          <a:prstGeom prst="rect">
+            <a:avLst/>
+          </a:prstGeom>
+          <a:noFill/>
+        </p:spPr>
+        <p:txBody>
+          <a:bodyPr wrap="square" anchor="t" lIns="0" rIns="0" tIns="0" bIns="0">
+            <a:spAutoFit/>
+          </a:bodyPr>
+          <a:lstStyle/>
+          <a:p>
+            <a:pPr algn="l">
+              <a:lnSpc>
+                <a:spcPct val="100000"/>
+              </a:lnSpc>
+              <a:spcBef>
+                <a:spcPts val="0"/>
+              </a:spcBef>
+              <a:spcAft>
+                <a:spcPts val="600"/>
+              </a:spcAft>
+            </a:pPr>
+            <a:r>
+              <a:rPr sz="1300" b="1">
+                <a:solidFill>
+                  <a:srgbClr val="7C83FF"/>
+                </a:solidFill>
+                <a:latin typeface="Segoe UI"/>
+              </a:rPr>
+              <a:t>ALLES AUF EINEN BLICK</a:t>
+            </a:r>
+          </a:p>
+        </p:txBody>
+      </p:sp>
+      <p:sp>
+        <p:nvSpPr>
+          <p:cNvPr id="3" name="TextBox 2"/>
+          <p:cNvSpPr txBox="1"/>
+          <p:nvPr/>
+        </p:nvSpPr>
+        <p:spPr>
+          <a:xfrm>
+            <a:off x="548640" y="1024128"/>
+            <a:ext cx="11064240" cy="822960"/>
+          </a:xfrm>
+          <a:prstGeom prst="rect">
+            <a:avLst/>
+          </a:prstGeom>
+          <a:noFill/>
+        </p:spPr>
+        <p:txBody>
+          <a:bodyPr wrap="square" anchor="t" lIns="0" rIns="0" tIns="0" bIns="0">
+            <a:spAutoFit/>
+          </a:bodyPr>
+          <a:lstStyle/>
+          <a:p>
+            <a:pPr algn="l">
+              <a:lnSpc>
+                <a:spcPct val="100000"/>
+              </a:lnSpc>
+              <a:spcBef>
+                <a:spcPts val="0"/>
+              </a:spcBef>
+              <a:spcAft>
+                <a:spcPts val="600"/>
+              </a:spcAft>
+            </a:pPr>
+            <a:r>
+              <a:rPr sz="3300" b="1">
+                <a:solidFill>
+                  <a:srgbClr val="F2F5FA"/>
+                </a:solidFill>
+                <a:latin typeface="Segoe UI"/>
+              </a:rPr>
+              <a:t>Feature-Highlights</a:t>
+            </a:r>
+          </a:p>
+        </p:txBody>
+      </p:sp>
+      <p:sp>
+        <p:nvSpPr>
+          <p:cNvPr id="4" name="Rounded Rectangle 3"/>
+          <p:cNvSpPr/>
+          <p:nvPr/>
+        </p:nvSpPr>
+        <p:spPr>
+          <a:xfrm>
+            <a:off x="548640" y="1783080"/>
+            <a:ext cx="3511296" cy="2240280"/>
+          </a:xfrm>
+          <a:prstGeom prst="roundRect">
+            <a:avLst/>
+          </a:prstGeom>
+          <a:solidFill>
+            <a:srgbClr val="151E33"/>
+          </a:solidFill>
+          <a:ln w="12700">
+            <a:solidFill>
+              <a:srgbClr val="2A3652"/>
+            </a:solidFill>
+          </a:ln>
+          <a:effectLst/>
+        </p:spPr>
+        <p:style>
+          <a:lnRef idx="1">
+            <a:schemeClr val="accent1"/>
+          </a:lnRef>
+          <a:fillRef idx="3">
+            <a:schemeClr val="accent1"/>
+          </a:fillRef>
+          <a:effectRef idx="2">
+            <a:schemeClr val="accent1"/>
+          </a:effectRef>
+          <a:fontRef idx="minor">
+            <a:schemeClr val="lt1"/>
+          </a:fontRef>
+        </p:style>
+        <p:txBody>
+          <a:bodyPr rtlCol="0" anchor="ctr"/>
+          <a:lstStyle/>
+          <a:p>
+            <a:pPr algn="ctr"/>
+          </a:p>
+        </p:txBody>
+      </p:sp>
+      <p:sp>
+        <p:nvSpPr>
+          <p:cNvPr id="5" name="TextBox 4"/>
+          <p:cNvSpPr txBox="1"/>
+          <p:nvPr/>
+        </p:nvSpPr>
+        <p:spPr>
+          <a:xfrm>
+            <a:off x="786384" y="1947672"/>
+            <a:ext cx="3145536" cy="365760"/>
+          </a:xfrm>
+          <a:prstGeom prst="rect">
+            <a:avLst/>
+          </a:prstGeom>
+          <a:noFill/>
+        </p:spPr>
+        <p:txBody>
+          <a:bodyPr wrap="square" anchor="t" lIns="0" rIns="0" tIns="0" bIns="0">
+            <a:spAutoFit/>
+          </a:bodyPr>
+          <a:lstStyle/>
+          <a:p>
+            <a:pPr algn="l">
+              <a:lnSpc>
+                <a:spcPct val="100000"/>
+              </a:lnSpc>
+              <a:spcBef>
+                <a:spcPts val="0"/>
+              </a:spcBef>
+              <a:spcAft>
+                <a:spcPts val="600"/>
+              </a:spcAft>
+            </a:pPr>
+            <a:r>
+              <a:rPr sz="1350" b="1">
+                <a:solidFill>
+                  <a:srgbClr val="7C83FF"/>
+                </a:solidFill>
+                <a:latin typeface="Segoe UI"/>
+              </a:rPr>
+              <a:t>Kapazität &amp; Planung</a:t>
+            </a:r>
+          </a:p>
+        </p:txBody>
+      </p:sp>
+      <p:sp>
+        <p:nvSpPr>
+          <p:cNvPr id="6" name="TextBox 5"/>
+          <p:cNvSpPr txBox="1"/>
+          <p:nvPr/>
+        </p:nvSpPr>
+        <p:spPr>
+          <a:xfrm>
+            <a:off x="786384" y="2368296"/>
+            <a:ext cx="3090672" cy="1554480"/>
+          </a:xfrm>
+          <a:prstGeom prst="rect">
+            <a:avLst/>
+          </a:prstGeom>
+          <a:noFill/>
+        </p:spPr>
+        <p:txBody>
+          <a:bodyPr wrap="square" anchor="t" lIns="0" rIns="0" tIns="0" bIns="0">
+            <a:spAutoFit/>
+          </a:bodyPr>
+          <a:lstStyle/>
+          <a:p>
+            <a:pPr algn="l">
+              <a:lnSpc>
+                <a:spcPct val="100000"/>
+              </a:lnSpc>
+              <a:spcBef>
+                <a:spcPts val="0"/>
+              </a:spcBef>
+              <a:spcAft>
+                <a:spcPts val="450"/>
+              </a:spcAft>
+            </a:pPr>
+            <a:r>
+              <a:rPr sz="1050" b="1">
+                <a:solidFill>
+                  <a:srgbClr val="34D399"/>
+                </a:solidFill>
+                <a:latin typeface="Segoe UI"/>
+              </a:rPr>
+              <a:t>•  </a:t>
+            </a:r>
+            <a:r>
+              <a:rPr sz="1050" b="0">
+                <a:solidFill>
+                  <a:srgbClr val="F2F5FA"/>
+                </a:solidFill>
+                <a:latin typeface="Segoe UI"/>
+              </a:rPr>
+              <a:t>Freie vCPU / RAM / Storage je Cluster</a:t>
+            </a:r>
+          </a:p>
+          <a:p>
+            <a:pPr algn="l">
+              <a:lnSpc>
+                <a:spcPct val="100000"/>
+              </a:lnSpc>
+              <a:spcBef>
+                <a:spcPts val="0"/>
+              </a:spcBef>
+              <a:spcAft>
+                <a:spcPts val="450"/>
+              </a:spcAft>
+            </a:pPr>
+            <a:r>
+              <a:rPr sz="1050" b="1">
+                <a:solidFill>
+                  <a:srgbClr val="34D399"/>
+                </a:solidFill>
+                <a:latin typeface="Segoe UI"/>
+              </a:rPr>
+              <a:t>•  </a:t>
+            </a:r>
+            <a:r>
+              <a:rPr sz="1050" b="0">
+                <a:solidFill>
+                  <a:srgbClr val="F2F5FA"/>
+                </a:solidFill>
+                <a:latin typeface="Segoe UI"/>
+              </a:rPr>
+              <a:t>N+1-Reserve &amp; vSAN-Faktor eingerechnet</a:t>
+            </a:r>
+          </a:p>
+          <a:p>
+            <a:pPr algn="l">
+              <a:lnSpc>
+                <a:spcPct val="100000"/>
+              </a:lnSpc>
+              <a:spcBef>
+                <a:spcPts val="0"/>
+              </a:spcBef>
+              <a:spcAft>
+                <a:spcPts val="450"/>
+              </a:spcAft>
+            </a:pPr>
+            <a:r>
+              <a:rPr sz="1050" b="1">
+                <a:solidFill>
+                  <a:srgbClr val="34D399"/>
+                </a:solidFill>
+                <a:latin typeface="Segoe UI"/>
+              </a:rPr>
+              <a:t>•  </a:t>
+            </a:r>
+            <a:r>
+              <a:rPr sz="1050" b="0">
+                <a:solidFill>
+                  <a:srgbClr val="F2F5FA"/>
+                </a:solidFill>
+                <a:latin typeface="Segoe UI"/>
+              </a:rPr>
+              <a:t>Tanzu-/K8s-Namespaces zählen mit</a:t>
+            </a:r>
+          </a:p>
+          <a:p>
+            <a:pPr algn="l">
+              <a:lnSpc>
+                <a:spcPct val="100000"/>
+              </a:lnSpc>
+              <a:spcBef>
+                <a:spcPts val="0"/>
+              </a:spcBef>
+              <a:spcAft>
+                <a:spcPts val="450"/>
+              </a:spcAft>
+            </a:pPr>
+            <a:r>
+              <a:rPr sz="1050" b="1">
+                <a:solidFill>
+                  <a:srgbClr val="34D399"/>
+                </a:solidFill>
+                <a:latin typeface="Segoe UI"/>
+              </a:rPr>
+              <a:t>•  </a:t>
+            </a:r>
+            <a:r>
+              <a:rPr sz="1050" b="0">
+                <a:solidFill>
+                  <a:srgbClr val="F2F5FA"/>
+                </a:solidFill>
+                <a:latin typeface="Segoe UI"/>
+              </a:rPr>
+              <a:t>Workload aus vROps · 2-Jahres-Trends</a:t>
+            </a:r>
+          </a:p>
+        </p:txBody>
+      </p:sp>
+      <p:sp>
+        <p:nvSpPr>
+          <p:cNvPr id="7" name="Rounded Rectangle 6"/>
+          <p:cNvSpPr/>
+          <p:nvPr/>
+        </p:nvSpPr>
+        <p:spPr>
+          <a:xfrm>
+            <a:off x="4334255" y="1783080"/>
+            <a:ext cx="3511296" cy="2240280"/>
+          </a:xfrm>
+          <a:prstGeom prst="roundRect">
+            <a:avLst/>
+          </a:prstGeom>
+          <a:solidFill>
+            <a:srgbClr val="151E33"/>
+          </a:solidFill>
+          <a:ln w="12700">
+            <a:solidFill>
+              <a:srgbClr val="2A3652"/>
+            </a:solidFill>
+          </a:ln>
+          <a:effectLst/>
+        </p:spPr>
+        <p:style>
+          <a:lnRef idx="1">
+            <a:schemeClr val="accent1"/>
+          </a:lnRef>
+          <a:fillRef idx="3">
+            <a:schemeClr val="accent1"/>
+          </a:fillRef>
+          <a:effectRef idx="2">
+            <a:schemeClr val="accent1"/>
+          </a:effectRef>
+          <a:fontRef idx="minor">
+            <a:schemeClr val="lt1"/>
+          </a:fontRef>
+        </p:style>
+        <p:txBody>
+          <a:bodyPr rtlCol="0" anchor="ctr"/>
+          <a:lstStyle/>
+          <a:p>
+            <a:pPr algn="ctr"/>
+          </a:p>
+        </p:txBody>
+      </p:sp>
+      <p:sp>
+        <p:nvSpPr>
+          <p:cNvPr id="8" name="TextBox 7"/>
+          <p:cNvSpPr txBox="1"/>
+          <p:nvPr/>
+        </p:nvSpPr>
+        <p:spPr>
+          <a:xfrm>
+            <a:off x="4571999" y="1947672"/>
+            <a:ext cx="3145536" cy="365760"/>
+          </a:xfrm>
+          <a:prstGeom prst="rect">
+            <a:avLst/>
+          </a:prstGeom>
+          <a:noFill/>
+        </p:spPr>
+        <p:txBody>
+          <a:bodyPr wrap="square" anchor="t" lIns="0" rIns="0" tIns="0" bIns="0">
+            <a:spAutoFit/>
+          </a:bodyPr>
+          <a:lstStyle/>
+          <a:p>
+            <a:pPr algn="l">
+              <a:lnSpc>
+                <a:spcPct val="100000"/>
+              </a:lnSpc>
+              <a:spcBef>
+                <a:spcPts val="0"/>
+              </a:spcBef>
+              <a:spcAft>
+                <a:spcPts val="600"/>
+              </a:spcAft>
+            </a:pPr>
+            <a:r>
+              <a:rPr sz="1350" b="1">
+                <a:solidFill>
+                  <a:srgbClr val="7C83FF"/>
+                </a:solidFill>
+                <a:latin typeface="Segoe UI"/>
+              </a:rPr>
+              <a:t>Governance &amp; Freigaben</a:t>
+            </a:r>
+          </a:p>
+        </p:txBody>
+      </p:sp>
+      <p:sp>
+        <p:nvSpPr>
+          <p:cNvPr id="9" name="TextBox 8"/>
+          <p:cNvSpPr txBox="1"/>
+          <p:nvPr/>
+        </p:nvSpPr>
+        <p:spPr>
+          <a:xfrm>
+            <a:off x="4571999" y="2368296"/>
+            <a:ext cx="3090672" cy="1554480"/>
+          </a:xfrm>
+          <a:prstGeom prst="rect">
+            <a:avLst/>
+          </a:prstGeom>
+          <a:noFill/>
+        </p:spPr>
+        <p:txBody>
+          <a:bodyPr wrap="square" anchor="t" lIns="0" rIns="0" tIns="0" bIns="0">
+            <a:spAutoFit/>
+          </a:bodyPr>
+          <a:lstStyle/>
+          <a:p>
+            <a:pPr algn="l">
+              <a:lnSpc>
+                <a:spcPct val="100000"/>
+              </a:lnSpc>
+              <a:spcBef>
+                <a:spcPts val="0"/>
+              </a:spcBef>
+              <a:spcAft>
+                <a:spcPts val="450"/>
+              </a:spcAft>
+            </a:pPr>
+            <a:r>
+              <a:rPr sz="1050" b="1">
+                <a:solidFill>
+                  <a:srgbClr val="34D399"/>
+                </a:solidFill>
+                <a:latin typeface="Segoe UI"/>
+              </a:rPr>
+              <a:t>•  </a:t>
+            </a:r>
+            <a:r>
+              <a:rPr sz="1050" b="0">
+                <a:solidFill>
+                  <a:srgbClr val="F2F5FA"/>
+                </a:solidFill>
+                <a:latin typeface="Segoe UI"/>
+              </a:rPr>
+              <a:t>Mehrstufiger Genehmigungs-Workflow</a:t>
+            </a:r>
+          </a:p>
+          <a:p>
+            <a:pPr algn="l">
+              <a:lnSpc>
+                <a:spcPct val="100000"/>
+              </a:lnSpc>
+              <a:spcBef>
+                <a:spcPts val="0"/>
+              </a:spcBef>
+              <a:spcAft>
+                <a:spcPts val="450"/>
+              </a:spcAft>
+            </a:pPr>
+            <a:r>
+              <a:rPr sz="1050" b="1">
+                <a:solidFill>
+                  <a:srgbClr val="34D399"/>
+                </a:solidFill>
+                <a:latin typeface="Segoe UI"/>
+              </a:rPr>
+              <a:t>•  </a:t>
+            </a:r>
+            <a:r>
+              <a:rPr sz="1050" b="0">
+                <a:solidFill>
+                  <a:srgbClr val="F2F5FA"/>
+                </a:solidFill>
+                <a:latin typeface="Segoe UI"/>
+              </a:rPr>
+              <a:t>Auto-Freigabe nach Schwellen</a:t>
+            </a:r>
+          </a:p>
+          <a:p>
+            <a:pPr algn="l">
+              <a:lnSpc>
+                <a:spcPct val="100000"/>
+              </a:lnSpc>
+              <a:spcBef>
+                <a:spcPts val="0"/>
+              </a:spcBef>
+              <a:spcAft>
+                <a:spcPts val="450"/>
+              </a:spcAft>
+            </a:pPr>
+            <a:r>
+              <a:rPr sz="1050" b="1">
+                <a:solidFill>
+                  <a:srgbClr val="34D399"/>
+                </a:solidFill>
+                <a:latin typeface="Segoe UI"/>
+              </a:rPr>
+              <a:t>•  </a:t>
+            </a:r>
+            <a:r>
+              <a:rPr sz="1050" b="0">
+                <a:solidFill>
+                  <a:srgbClr val="F2F5FA"/>
+                </a:solidFill>
+                <a:latin typeface="Segoe UI"/>
+              </a:rPr>
+              <a:t>Lückenloses Audit-Log</a:t>
+            </a:r>
+          </a:p>
+          <a:p>
+            <a:pPr algn="l">
+              <a:lnSpc>
+                <a:spcPct val="100000"/>
+              </a:lnSpc>
+              <a:spcBef>
+                <a:spcPts val="0"/>
+              </a:spcBef>
+              <a:spcAft>
+                <a:spcPts val="450"/>
+              </a:spcAft>
+            </a:pPr>
+            <a:r>
+              <a:rPr sz="1050" b="1">
+                <a:solidFill>
+                  <a:srgbClr val="34D399"/>
+                </a:solidFill>
+                <a:latin typeface="Segoe UI"/>
+              </a:rPr>
+              <a:t>•  </a:t>
+            </a:r>
+            <a:r>
+              <a:rPr sz="1050" b="0">
+                <a:solidFill>
+                  <a:srgbClr val="F2F5FA"/>
+                </a:solidFill>
+                <a:latin typeface="Segoe UI"/>
+              </a:rPr>
+              <a:t>Mail-Benachrichtigungen &amp; Erinnerungen</a:t>
+            </a:r>
+          </a:p>
+        </p:txBody>
+      </p:sp>
+      <p:sp>
+        <p:nvSpPr>
+          <p:cNvPr id="10" name="Rounded Rectangle 9"/>
+          <p:cNvSpPr/>
+          <p:nvPr/>
+        </p:nvSpPr>
+        <p:spPr>
+          <a:xfrm>
+            <a:off x="8119871" y="1783080"/>
+            <a:ext cx="3511296" cy="2240280"/>
+          </a:xfrm>
+          <a:prstGeom prst="roundRect">
+            <a:avLst/>
+          </a:prstGeom>
+          <a:solidFill>
+            <a:srgbClr val="151E33"/>
+          </a:solidFill>
+          <a:ln w="12700">
+            <a:solidFill>
+              <a:srgbClr val="2A3652"/>
+            </a:solidFill>
+          </a:ln>
+          <a:effectLst/>
+        </p:spPr>
+        <p:style>
+          <a:lnRef idx="1">
+            <a:schemeClr val="accent1"/>
+          </a:lnRef>
+          <a:fillRef idx="3">
+            <a:schemeClr val="accent1"/>
+          </a:fillRef>
+          <a:effectRef idx="2">
+            <a:schemeClr val="accent1"/>
+          </a:effectRef>
+          <a:fontRef idx="minor">
+            <a:schemeClr val="lt1"/>
+          </a:fontRef>
+        </p:style>
+        <p:txBody>
+          <a:bodyPr rtlCol="0" anchor="ctr"/>
+          <a:lstStyle/>
+          <a:p>
+            <a:pPr algn="ctr"/>
+          </a:p>
+        </p:txBody>
+      </p:sp>
+      <p:sp>
+        <p:nvSpPr>
+          <p:cNvPr id="11" name="TextBox 10"/>
+          <p:cNvSpPr txBox="1"/>
+          <p:nvPr/>
+        </p:nvSpPr>
+        <p:spPr>
+          <a:xfrm>
+            <a:off x="8357615" y="1947672"/>
+            <a:ext cx="3145536" cy="365760"/>
+          </a:xfrm>
+          <a:prstGeom prst="rect">
+            <a:avLst/>
+          </a:prstGeom>
+          <a:noFill/>
+        </p:spPr>
+        <p:txBody>
+          <a:bodyPr wrap="square" anchor="t" lIns="0" rIns="0" tIns="0" bIns="0">
+            <a:spAutoFit/>
+          </a:bodyPr>
+          <a:lstStyle/>
+          <a:p>
+            <a:pPr algn="l">
+              <a:lnSpc>
+                <a:spcPct val="100000"/>
+              </a:lnSpc>
+              <a:spcBef>
+                <a:spcPts val="0"/>
+              </a:spcBef>
+              <a:spcAft>
+                <a:spcPts val="600"/>
+              </a:spcAft>
+            </a:pPr>
+            <a:r>
+              <a:rPr sz="1350" b="1">
+                <a:solidFill>
+                  <a:srgbClr val="7C83FF"/>
+                </a:solidFill>
+                <a:latin typeface="Segoe UI"/>
+              </a:rPr>
+              <a:t>Netzwerk &amp; Storage</a:t>
+            </a:r>
+          </a:p>
+        </p:txBody>
+      </p:sp>
+      <p:sp>
+        <p:nvSpPr>
+          <p:cNvPr id="12" name="TextBox 11"/>
+          <p:cNvSpPr txBox="1"/>
+          <p:nvPr/>
+        </p:nvSpPr>
+        <p:spPr>
+          <a:xfrm>
+            <a:off x="8357615" y="2368296"/>
+            <a:ext cx="3090672" cy="1554480"/>
+          </a:xfrm>
+          <a:prstGeom prst="rect">
+            <a:avLst/>
+          </a:prstGeom>
+          <a:noFill/>
+        </p:spPr>
+        <p:txBody>
+          <a:bodyPr wrap="square" anchor="t" lIns="0" rIns="0" tIns="0" bIns="0">
+            <a:spAutoFit/>
+          </a:bodyPr>
+          <a:lstStyle/>
+          <a:p>
+            <a:pPr algn="l">
+              <a:lnSpc>
+                <a:spcPct val="100000"/>
+              </a:lnSpc>
+              <a:spcBef>
+                <a:spcPts val="0"/>
+              </a:spcBef>
+              <a:spcAft>
+                <a:spcPts val="450"/>
+              </a:spcAft>
+            </a:pPr>
+            <a:r>
+              <a:rPr sz="1050" b="1">
+                <a:solidFill>
+                  <a:srgbClr val="34D399"/>
+                </a:solidFill>
+                <a:latin typeface="Segoe UI"/>
+              </a:rPr>
+              <a:t>•  </a:t>
+            </a:r>
+            <a:r>
+              <a:rPr sz="1050" b="0">
+                <a:solidFill>
+                  <a:srgbClr val="F2F5FA"/>
+                </a:solidFill>
+                <a:latin typeface="Segoe UI"/>
+              </a:rPr>
+              <a:t>VLAN-/Portgruppen-Suche</a:t>
+            </a:r>
+          </a:p>
+          <a:p>
+            <a:pPr algn="l">
+              <a:lnSpc>
+                <a:spcPct val="100000"/>
+              </a:lnSpc>
+              <a:spcBef>
+                <a:spcPts val="0"/>
+              </a:spcBef>
+              <a:spcAft>
+                <a:spcPts val="450"/>
+              </a:spcAft>
+            </a:pPr>
+            <a:r>
+              <a:rPr sz="1050" b="1">
+                <a:solidFill>
+                  <a:srgbClr val="34D399"/>
+                </a:solidFill>
+                <a:latin typeface="Segoe UI"/>
+              </a:rPr>
+              <a:t>•  </a:t>
+            </a:r>
+            <a:r>
+              <a:rPr sz="1050" b="0">
+                <a:solidFill>
+                  <a:srgbClr val="F2F5FA"/>
+                </a:solidFill>
+                <a:latin typeface="Segoe UI"/>
+              </a:rPr>
+              <a:t>LUN-Drilldown inkl. NAA &amp; WWPN</a:t>
+            </a:r>
+          </a:p>
+          <a:p>
+            <a:pPr algn="l">
+              <a:lnSpc>
+                <a:spcPct val="100000"/>
+              </a:lnSpc>
+              <a:spcBef>
+                <a:spcPts val="0"/>
+              </a:spcBef>
+              <a:spcAft>
+                <a:spcPts val="450"/>
+              </a:spcAft>
+            </a:pPr>
+            <a:r>
+              <a:rPr sz="1050" b="1">
+                <a:solidFill>
+                  <a:srgbClr val="34D399"/>
+                </a:solidFill>
+                <a:latin typeface="Segoe UI"/>
+              </a:rPr>
+              <a:t>•  </a:t>
+            </a:r>
+            <a:r>
+              <a:rPr sz="1050" b="0">
+                <a:solidFill>
+                  <a:srgbClr val="F2F5FA"/>
+                </a:solidFill>
+                <a:latin typeface="Segoe UI"/>
+              </a:rPr>
+              <a:t>Storage-Brücke ans Team (API/CSV)</a:t>
+            </a:r>
+          </a:p>
+          <a:p>
+            <a:pPr algn="l">
+              <a:lnSpc>
+                <a:spcPct val="100000"/>
+              </a:lnSpc>
+              <a:spcBef>
+                <a:spcPts val="0"/>
+              </a:spcBef>
+              <a:spcAft>
+                <a:spcPts val="450"/>
+              </a:spcAft>
+            </a:pPr>
+            <a:r>
+              <a:rPr sz="1050" b="1">
+                <a:solidFill>
+                  <a:srgbClr val="34D399"/>
+                </a:solidFill>
+                <a:latin typeface="Segoe UI"/>
+              </a:rPr>
+              <a:t>•  </a:t>
+            </a:r>
+            <a:r>
+              <a:rPr sz="1050" b="0">
+                <a:solidFill>
+                  <a:srgbClr val="F2F5FA"/>
+                </a:solidFill>
+                <a:latin typeface="Segoe UI"/>
+              </a:rPr>
+              <a:t>Mindest-LUN- &amp; Namensfilter</a:t>
+            </a:r>
+          </a:p>
+        </p:txBody>
+      </p:sp>
+      <p:sp>
+        <p:nvSpPr>
+          <p:cNvPr id="13" name="Rounded Rectangle 12"/>
+          <p:cNvSpPr/>
+          <p:nvPr/>
+        </p:nvSpPr>
+        <p:spPr>
+          <a:xfrm>
+            <a:off x="548640" y="4160520"/>
+            <a:ext cx="3511296" cy="2240280"/>
+          </a:xfrm>
+          <a:prstGeom prst="roundRect">
+            <a:avLst/>
+          </a:prstGeom>
+          <a:solidFill>
+            <a:srgbClr val="151E33"/>
+          </a:solidFill>
+          <a:ln w="12700">
+            <a:solidFill>
+              <a:srgbClr val="2A3652"/>
+            </a:solidFill>
+          </a:ln>
+          <a:effectLst/>
+        </p:spPr>
+        <p:style>
+          <a:lnRef idx="1">
+            <a:schemeClr val="accent1"/>
+          </a:lnRef>
+          <a:fillRef idx="3">
+            <a:schemeClr val="accent1"/>
+          </a:fillRef>
+          <a:effectRef idx="2">
+            <a:schemeClr val="accent1"/>
+          </a:effectRef>
+          <a:fontRef idx="minor">
+            <a:schemeClr val="lt1"/>
+          </a:fontRef>
+        </p:style>
+        <p:txBody>
+          <a:bodyPr rtlCol="0" anchor="ctr"/>
+          <a:lstStyle/>
+          <a:p>
+            <a:pPr algn="ctr"/>
+          </a:p>
+        </p:txBody>
+      </p:sp>
+      <p:sp>
+        <p:nvSpPr>
+          <p:cNvPr id="14" name="TextBox 13"/>
+          <p:cNvSpPr txBox="1"/>
+          <p:nvPr/>
+        </p:nvSpPr>
+        <p:spPr>
+          <a:xfrm>
+            <a:off x="786384" y="4325112"/>
+            <a:ext cx="3145536" cy="365760"/>
+          </a:xfrm>
+          <a:prstGeom prst="rect">
+            <a:avLst/>
+          </a:prstGeom>
+          <a:noFill/>
+        </p:spPr>
+        <p:txBody>
+          <a:bodyPr wrap="square" anchor="t" lIns="0" rIns="0" tIns="0" bIns="0">
+            <a:spAutoFit/>
+          </a:bodyPr>
+          <a:lstStyle/>
+          <a:p>
+            <a:pPr algn="l">
+              <a:lnSpc>
+                <a:spcPct val="100000"/>
+              </a:lnSpc>
+              <a:spcBef>
+                <a:spcPts val="0"/>
+              </a:spcBef>
+              <a:spcAft>
+                <a:spcPts val="600"/>
+              </a:spcAft>
+            </a:pPr>
+            <a:r>
+              <a:rPr sz="1350" b="1">
+                <a:solidFill>
+                  <a:srgbClr val="7C83FF"/>
+                </a:solidFill>
+                <a:latin typeface="Segoe UI"/>
+              </a:rPr>
+              <a:t>Rollen &amp; Sicherheit</a:t>
+            </a:r>
+          </a:p>
+        </p:txBody>
+      </p:sp>
+      <p:sp>
+        <p:nvSpPr>
+          <p:cNvPr id="15" name="TextBox 14"/>
+          <p:cNvSpPr txBox="1"/>
+          <p:nvPr/>
+        </p:nvSpPr>
+        <p:spPr>
+          <a:xfrm>
+            <a:off x="786384" y="4745736"/>
+            <a:ext cx="3090672" cy="1554480"/>
+          </a:xfrm>
+          <a:prstGeom prst="rect">
+            <a:avLst/>
+          </a:prstGeom>
+          <a:noFill/>
+        </p:spPr>
+        <p:txBody>
+          <a:bodyPr wrap="square" anchor="t" lIns="0" rIns="0" tIns="0" bIns="0">
+            <a:spAutoFit/>
+          </a:bodyPr>
+          <a:lstStyle/>
+          <a:p>
+            <a:pPr algn="l">
+              <a:lnSpc>
+                <a:spcPct val="100000"/>
+              </a:lnSpc>
+              <a:spcBef>
+                <a:spcPts val="0"/>
+              </a:spcBef>
+              <a:spcAft>
+                <a:spcPts val="450"/>
+              </a:spcAft>
+            </a:pPr>
+            <a:r>
+              <a:rPr sz="1050" b="1">
+                <a:solidFill>
+                  <a:srgbClr val="34D399"/>
+                </a:solidFill>
+                <a:latin typeface="Segoe UI"/>
+              </a:rPr>
+              <a:t>•  </a:t>
+            </a:r>
+            <a:r>
+              <a:rPr sz="1050" b="0">
+                <a:solidFill>
+                  <a:srgbClr val="F2F5FA"/>
+                </a:solidFill>
+                <a:latin typeface="Segoe UI"/>
+              </a:rPr>
+              <a:t>AD-Anmeldung &amp; AD-Gruppen</a:t>
+            </a:r>
+          </a:p>
+          <a:p>
+            <a:pPr algn="l">
+              <a:lnSpc>
+                <a:spcPct val="100000"/>
+              </a:lnSpc>
+              <a:spcBef>
+                <a:spcPts val="0"/>
+              </a:spcBef>
+              <a:spcAft>
+                <a:spcPts val="450"/>
+              </a:spcAft>
+            </a:pPr>
+            <a:r>
+              <a:rPr sz="1050" b="1">
+                <a:solidFill>
+                  <a:srgbClr val="34D399"/>
+                </a:solidFill>
+                <a:latin typeface="Segoe UI"/>
+              </a:rPr>
+              <a:t>•  </a:t>
+            </a:r>
+            <a:r>
+              <a:rPr sz="1050" b="0">
+                <a:solidFill>
+                  <a:srgbClr val="F2F5FA"/>
+                </a:solidFill>
+                <a:latin typeface="Segoe UI"/>
+              </a:rPr>
+              <a:t>Sichtbarkeits-Matrix je Rolle</a:t>
+            </a:r>
+          </a:p>
+          <a:p>
+            <a:pPr algn="l">
+              <a:lnSpc>
+                <a:spcPct val="100000"/>
+              </a:lnSpc>
+              <a:spcBef>
+                <a:spcPts val="0"/>
+              </a:spcBef>
+              <a:spcAft>
+                <a:spcPts val="450"/>
+              </a:spcAft>
+            </a:pPr>
+            <a:r>
+              <a:rPr sz="1050" b="1">
+                <a:solidFill>
+                  <a:srgbClr val="34D399"/>
+                </a:solidFill>
+                <a:latin typeface="Segoe UI"/>
+              </a:rPr>
+              <a:t>•  </a:t>
+            </a:r>
+            <a:r>
+              <a:rPr sz="1050" b="0">
+                <a:solidFill>
+                  <a:srgbClr val="F2F5FA"/>
+                </a:solidFill>
+                <a:latin typeface="Segoe UI"/>
+              </a:rPr>
+              <a:t>vROps-Quellen-Filter je Nutzer</a:t>
+            </a:r>
+          </a:p>
+          <a:p>
+            <a:pPr algn="l">
+              <a:lnSpc>
+                <a:spcPct val="100000"/>
+              </a:lnSpc>
+              <a:spcBef>
+                <a:spcPts val="0"/>
+              </a:spcBef>
+              <a:spcAft>
+                <a:spcPts val="450"/>
+              </a:spcAft>
+            </a:pPr>
+            <a:r>
+              <a:rPr sz="1050" b="1">
+                <a:solidFill>
+                  <a:srgbClr val="34D399"/>
+                </a:solidFill>
+                <a:latin typeface="Segoe UI"/>
+              </a:rPr>
+              <a:t>•  </a:t>
+            </a:r>
+            <a:r>
+              <a:rPr sz="1050" b="0">
+                <a:solidFill>
+                  <a:srgbClr val="F2F5FA"/>
+                </a:solidFill>
+                <a:latin typeface="Segoe UI"/>
+              </a:rPr>
+              <a:t>CSP-Härtung · 5 CI-Scanner</a:t>
+            </a:r>
+          </a:p>
+        </p:txBody>
+      </p:sp>
+      <p:sp>
+        <p:nvSpPr>
+          <p:cNvPr id="16" name="Rounded Rectangle 15"/>
+          <p:cNvSpPr/>
+          <p:nvPr/>
+        </p:nvSpPr>
+        <p:spPr>
+          <a:xfrm>
+            <a:off x="4334255" y="4160520"/>
+            <a:ext cx="3511296" cy="2240280"/>
+          </a:xfrm>
+          <a:prstGeom prst="roundRect">
+            <a:avLst/>
+          </a:prstGeom>
+          <a:solidFill>
+            <a:srgbClr val="151E33"/>
+          </a:solidFill>
+          <a:ln w="12700">
+            <a:solidFill>
+              <a:srgbClr val="2A3652"/>
+            </a:solidFill>
+          </a:ln>
+          <a:effectLst/>
+        </p:spPr>
+        <p:style>
+          <a:lnRef idx="1">
+            <a:schemeClr val="accent1"/>
+          </a:lnRef>
+          <a:fillRef idx="3">
+            <a:schemeClr val="accent1"/>
+          </a:fillRef>
+          <a:effectRef idx="2">
+            <a:schemeClr val="accent1"/>
+          </a:effectRef>
+          <a:fontRef idx="minor">
+            <a:schemeClr val="lt1"/>
+          </a:fontRef>
+        </p:style>
+        <p:txBody>
+          <a:bodyPr rtlCol="0" anchor="ctr"/>
+          <a:lstStyle/>
+          <a:p>
+            <a:pPr algn="ctr"/>
+          </a:p>
+        </p:txBody>
+      </p:sp>
+      <p:sp>
+        <p:nvSpPr>
+          <p:cNvPr id="17" name="TextBox 16"/>
+          <p:cNvSpPr txBox="1"/>
+          <p:nvPr/>
+        </p:nvSpPr>
+        <p:spPr>
+          <a:xfrm>
+            <a:off x="4571999" y="4325112"/>
+            <a:ext cx="3145536" cy="365760"/>
+          </a:xfrm>
+          <a:prstGeom prst="rect">
+            <a:avLst/>
+          </a:prstGeom>
+          <a:noFill/>
+        </p:spPr>
+        <p:txBody>
+          <a:bodyPr wrap="square" anchor="t" lIns="0" rIns="0" tIns="0" bIns="0">
+            <a:spAutoFit/>
+          </a:bodyPr>
+          <a:lstStyle/>
+          <a:p>
+            <a:pPr algn="l">
+              <a:lnSpc>
+                <a:spcPct val="100000"/>
+              </a:lnSpc>
+              <a:spcBef>
+                <a:spcPts val="0"/>
+              </a:spcBef>
+              <a:spcAft>
+                <a:spcPts val="600"/>
+              </a:spcAft>
+            </a:pPr>
+            <a:r>
+              <a:rPr sz="1350" b="1">
+                <a:solidFill>
+                  <a:srgbClr val="7C83FF"/>
+                </a:solidFill>
+                <a:latin typeface="Segoe UI"/>
+              </a:rPr>
+              <a:t>Integration &amp; Betrieb</a:t>
+            </a:r>
+          </a:p>
+        </p:txBody>
+      </p:sp>
+      <p:sp>
+        <p:nvSpPr>
+          <p:cNvPr id="18" name="TextBox 17"/>
+          <p:cNvSpPr txBox="1"/>
+          <p:nvPr/>
+        </p:nvSpPr>
+        <p:spPr>
+          <a:xfrm>
+            <a:off x="4571999" y="4745736"/>
+            <a:ext cx="3090672" cy="1554480"/>
+          </a:xfrm>
+          <a:prstGeom prst="rect">
+            <a:avLst/>
+          </a:prstGeom>
+          <a:noFill/>
+        </p:spPr>
+        <p:txBody>
+          <a:bodyPr wrap="square" anchor="t" lIns="0" rIns="0" tIns="0" bIns="0">
+            <a:spAutoFit/>
+          </a:bodyPr>
+          <a:lstStyle/>
+          <a:p>
+            <a:pPr algn="l">
+              <a:lnSpc>
+                <a:spcPct val="100000"/>
+              </a:lnSpc>
+              <a:spcBef>
+                <a:spcPts val="0"/>
+              </a:spcBef>
+              <a:spcAft>
+                <a:spcPts val="450"/>
+              </a:spcAft>
+            </a:pPr>
+            <a:r>
+              <a:rPr sz="1050" b="1">
+                <a:solidFill>
+                  <a:srgbClr val="34D399"/>
+                </a:solidFill>
+                <a:latin typeface="Segoe UI"/>
+              </a:rPr>
+              <a:t>•  </a:t>
+            </a:r>
+            <a:r>
+              <a:rPr sz="1050" b="0">
+                <a:solidFill>
+                  <a:srgbClr val="F2F5FA"/>
+                </a:solidFill>
+                <a:latin typeface="Segoe UI"/>
+              </a:rPr>
+              <a:t>Multi-vROps + Offline-Import</a:t>
+            </a:r>
+          </a:p>
+          <a:p>
+            <a:pPr algn="l">
+              <a:lnSpc>
+                <a:spcPct val="100000"/>
+              </a:lnSpc>
+              <a:spcBef>
+                <a:spcPts val="0"/>
+              </a:spcBef>
+              <a:spcAft>
+                <a:spcPts val="450"/>
+              </a:spcAft>
+            </a:pPr>
+            <a:r>
+              <a:rPr sz="1050" b="1">
+                <a:solidFill>
+                  <a:srgbClr val="34D399"/>
+                </a:solidFill>
+                <a:latin typeface="Segoe UI"/>
+              </a:rPr>
+              <a:t>•  </a:t>
+            </a:r>
+            <a:r>
+              <a:rPr sz="1050" b="0">
+                <a:solidFill>
+                  <a:srgbClr val="F2F5FA"/>
+                </a:solidFill>
+                <a:latin typeface="Segoe UI"/>
+              </a:rPr>
+              <a:t>Lesende v1-API (Bearer-Token)</a:t>
+            </a:r>
+          </a:p>
+          <a:p>
+            <a:pPr algn="l">
+              <a:lnSpc>
+                <a:spcPct val="100000"/>
+              </a:lnSpc>
+              <a:spcBef>
+                <a:spcPts val="0"/>
+              </a:spcBef>
+              <a:spcAft>
+                <a:spcPts val="450"/>
+              </a:spcAft>
+            </a:pPr>
+            <a:r>
+              <a:rPr sz="1050" b="1">
+                <a:solidFill>
+                  <a:srgbClr val="34D399"/>
+                </a:solidFill>
+                <a:latin typeface="Segoe UI"/>
+              </a:rPr>
+              <a:t>•  </a:t>
+            </a:r>
+            <a:r>
+              <a:rPr sz="1050" b="0">
+                <a:solidFill>
+                  <a:srgbClr val="F2F5FA"/>
+                </a:solidFill>
+                <a:latin typeface="Segoe UI"/>
+              </a:rPr>
+              <a:t>SFTP-Backup · JSON oder SQLite</a:t>
+            </a:r>
+          </a:p>
+          <a:p>
+            <a:pPr algn="l">
+              <a:lnSpc>
+                <a:spcPct val="100000"/>
+              </a:lnSpc>
+              <a:spcBef>
+                <a:spcPts val="0"/>
+              </a:spcBef>
+              <a:spcAft>
+                <a:spcPts val="450"/>
+              </a:spcAft>
+            </a:pPr>
+            <a:r>
+              <a:rPr sz="1050" b="1">
+                <a:solidFill>
+                  <a:srgbClr val="34D399"/>
+                </a:solidFill>
+                <a:latin typeface="Segoe UI"/>
+              </a:rPr>
+              <a:t>•  </a:t>
+            </a:r>
+            <a:r>
+              <a:rPr sz="1050" b="0">
+                <a:solidFill>
+                  <a:srgbClr val="F2F5FA"/>
+                </a:solidFill>
+                <a:latin typeface="Segoe UI"/>
+              </a:rPr>
+              <a:t>/healthz · Proxy-fähig</a:t>
+            </a:r>
+          </a:p>
+        </p:txBody>
+      </p:sp>
+      <p:sp>
+        <p:nvSpPr>
+          <p:cNvPr id="19" name="Rounded Rectangle 18"/>
+          <p:cNvSpPr/>
+          <p:nvPr/>
+        </p:nvSpPr>
+        <p:spPr>
+          <a:xfrm>
+            <a:off x="8119871" y="4160520"/>
+            <a:ext cx="3511296" cy="2240280"/>
+          </a:xfrm>
+          <a:prstGeom prst="roundRect">
+            <a:avLst/>
+          </a:prstGeom>
+          <a:solidFill>
+            <a:srgbClr val="151E33"/>
+          </a:solidFill>
+          <a:ln w="12700">
+            <a:solidFill>
+              <a:srgbClr val="2A3652"/>
+            </a:solidFill>
+          </a:ln>
+          <a:effectLst/>
+        </p:spPr>
+        <p:style>
+          <a:lnRef idx="1">
+            <a:schemeClr val="accent1"/>
+          </a:lnRef>
+          <a:fillRef idx="3">
+            <a:schemeClr val="accent1"/>
+          </a:fillRef>
+          <a:effectRef idx="2">
+            <a:schemeClr val="accent1"/>
+          </a:effectRef>
+          <a:fontRef idx="minor">
+            <a:schemeClr val="lt1"/>
+          </a:fontRef>
+        </p:style>
+        <p:txBody>
+          <a:bodyPr rtlCol="0" anchor="ctr"/>
+          <a:lstStyle/>
+          <a:p>
+            <a:pPr algn="ctr"/>
+          </a:p>
+        </p:txBody>
+      </p:sp>
+      <p:sp>
+        <p:nvSpPr>
+          <p:cNvPr id="20" name="TextBox 19"/>
+          <p:cNvSpPr txBox="1"/>
+          <p:nvPr/>
+        </p:nvSpPr>
+        <p:spPr>
+          <a:xfrm>
+            <a:off x="8357615" y="4325112"/>
+            <a:ext cx="3145536" cy="365760"/>
+          </a:xfrm>
+          <a:prstGeom prst="rect">
+            <a:avLst/>
+          </a:prstGeom>
+          <a:noFill/>
+        </p:spPr>
+        <p:txBody>
+          <a:bodyPr wrap="square" anchor="t" lIns="0" rIns="0" tIns="0" bIns="0">
+            <a:spAutoFit/>
+          </a:bodyPr>
+          <a:lstStyle/>
+          <a:p>
+            <a:pPr algn="l">
+              <a:lnSpc>
+                <a:spcPct val="100000"/>
+              </a:lnSpc>
+              <a:spcBef>
+                <a:spcPts val="0"/>
+              </a:spcBef>
+              <a:spcAft>
+                <a:spcPts val="600"/>
+              </a:spcAft>
+            </a:pPr>
+            <a:r>
+              <a:rPr sz="1350" b="1">
+                <a:solidFill>
+                  <a:srgbClr val="7C83FF"/>
+                </a:solidFill>
+                <a:latin typeface="Segoe UI"/>
+              </a:rPr>
+              <a:t>Bedienung &amp; Doku</a:t>
+            </a:r>
+          </a:p>
+        </p:txBody>
+      </p:sp>
+      <p:sp>
+        <p:nvSpPr>
+          <p:cNvPr id="21" name="TextBox 20"/>
+          <p:cNvSpPr txBox="1"/>
+          <p:nvPr/>
+        </p:nvSpPr>
+        <p:spPr>
+          <a:xfrm>
+            <a:off x="8357615" y="4745736"/>
+            <a:ext cx="3090672" cy="1554480"/>
+          </a:xfrm>
+          <a:prstGeom prst="rect">
+            <a:avLst/>
+          </a:prstGeom>
+          <a:noFill/>
+        </p:spPr>
+        <p:txBody>
+          <a:bodyPr wrap="square" anchor="t" lIns="0" rIns="0" tIns="0" bIns="0">
+            <a:spAutoFit/>
+          </a:bodyPr>
+          <a:lstStyle/>
+          <a:p>
+            <a:pPr algn="l">
+              <a:lnSpc>
+                <a:spcPct val="100000"/>
+              </a:lnSpc>
+              <a:spcBef>
+                <a:spcPts val="0"/>
+              </a:spcBef>
+              <a:spcAft>
+                <a:spcPts val="450"/>
+              </a:spcAft>
+            </a:pPr>
+            <a:r>
+              <a:rPr sz="1050" b="1">
+                <a:solidFill>
+                  <a:srgbClr val="34D399"/>
+                </a:solidFill>
+                <a:latin typeface="Segoe UI"/>
+              </a:rPr>
+              <a:t>•  </a:t>
+            </a:r>
+            <a:r>
+              <a:rPr sz="1050" b="0">
+                <a:solidFill>
+                  <a:srgbClr val="F2F5FA"/>
+                </a:solidFill>
+                <a:latin typeface="Segoe UI"/>
+              </a:rPr>
+              <a:t>Zweisprachig DE/EN · Hell-/Dunkel-Modus</a:t>
+            </a:r>
+          </a:p>
+          <a:p>
+            <a:pPr algn="l">
+              <a:lnSpc>
+                <a:spcPct val="100000"/>
+              </a:lnSpc>
+              <a:spcBef>
+                <a:spcPts val="0"/>
+              </a:spcBef>
+              <a:spcAft>
+                <a:spcPts val="450"/>
+              </a:spcAft>
+            </a:pPr>
+            <a:r>
+              <a:rPr sz="1050" b="1">
+                <a:solidFill>
+                  <a:srgbClr val="34D399"/>
+                </a:solidFill>
+                <a:latin typeface="Segoe UI"/>
+              </a:rPr>
+              <a:t>•  </a:t>
+            </a:r>
+            <a:r>
+              <a:rPr sz="1050" b="0">
+                <a:solidFill>
+                  <a:srgbClr val="F2F5FA"/>
+                </a:solidFill>
+                <a:latin typeface="Segoe UI"/>
+              </a:rPr>
+              <a:t>Sortieren, Blättern, Spalten wählen</a:t>
+            </a:r>
+          </a:p>
+          <a:p>
+            <a:pPr algn="l">
+              <a:lnSpc>
+                <a:spcPct val="100000"/>
+              </a:lnSpc>
+              <a:spcBef>
+                <a:spcPts val="0"/>
+              </a:spcBef>
+              <a:spcAft>
+                <a:spcPts val="450"/>
+              </a:spcAft>
+            </a:pPr>
+            <a:r>
+              <a:rPr sz="1050" b="1">
+                <a:solidFill>
+                  <a:srgbClr val="34D399"/>
+                </a:solidFill>
+                <a:latin typeface="Segoe UI"/>
+              </a:rPr>
+              <a:t>•  </a:t>
+            </a:r>
+            <a:r>
+              <a:rPr sz="1050" b="0">
+                <a:solidFill>
+                  <a:srgbClr val="F2F5FA"/>
+                </a:solidFill>
+                <a:latin typeface="Segoe UI"/>
+              </a:rPr>
+              <a:t>Konfigurierbare Zeitzone</a:t>
+            </a:r>
+          </a:p>
+          <a:p>
+            <a:pPr algn="l">
+              <a:lnSpc>
+                <a:spcPct val="100000"/>
+              </a:lnSpc>
+              <a:spcBef>
+                <a:spcPts val="0"/>
+              </a:spcBef>
+              <a:spcAft>
+                <a:spcPts val="450"/>
+              </a:spcAft>
+            </a:pPr>
+            <a:r>
+              <a:rPr sz="1050" b="1">
+                <a:solidFill>
+                  <a:srgbClr val="34D399"/>
+                </a:solidFill>
+                <a:latin typeface="Segoe UI"/>
+              </a:rPr>
+              <a:t>•  </a:t>
+            </a:r>
+            <a:r>
+              <a:rPr sz="1050" b="0">
+                <a:solidFill>
+                  <a:srgbClr val="F2F5FA"/>
+                </a:solidFill>
+                <a:latin typeface="Segoe UI"/>
+              </a:rPr>
+              <a:t>Reviewer-Handbuch &amp; Architektur-Doku</a:t>
+            </a:r>
+          </a:p>
+        </p:txBody>
+      </p:sp>
+      <p:sp>
+        <p:nvSpPr>
+          <p:cNvPr id="22" name="Rectangle 21"/>
+          <p:cNvSpPr/>
+          <p:nvPr/>
+        </p:nvSpPr>
+        <p:spPr>
+          <a:xfrm>
+            <a:off x="0" y="6729984"/>
+            <a:ext cx="12191695" cy="128016"/>
+          </a:xfrm>
+          <a:prstGeom prst="rect">
+            <a:avLst/>
+          </a:prstGeom>
+          <a:solidFill>
+            <a:srgbClr val="7C83FF"/>
+          </a:solidFill>
+          <a:ln>
+            <a:noFill/>
+          </a:ln>
+          <a:effectLst/>
+        </p:spPr>
+        <p:style>
+          <a:lnRef idx="1">
+            <a:schemeClr val="accent1"/>
+          </a:lnRef>
+          <a:fillRef idx="3">
+            <a:schemeClr val="accent1"/>
+          </a:fillRef>
+          <a:effectRef idx="2">
+            <a:schemeClr val="accent1"/>
+          </a:effectRef>
+          <a:fontRef idx="minor">
+            <a:schemeClr val="lt1"/>
+          </a:fontRef>
+        </p:style>
+        <p:txBody>
+          <a:bodyPr rtlCol="0" anchor="ctr"/>
+          <a:lstStyle/>
+          <a:p>
+            <a:pPr algn="ctr"/>
+          </a:p>
+        </p:txBody>
+      </p:sp>
+      <p:sp>
+        <p:nvSpPr>
+          <p:cNvPr id="23" name="TextBox 22"/>
+          <p:cNvSpPr txBox="1"/>
+          <p:nvPr/>
+        </p:nvSpPr>
+        <p:spPr>
+          <a:xfrm>
+            <a:off x="10515600" y="6419088"/>
+            <a:ext cx="1554480" cy="274320"/>
+          </a:xfrm>
+          <a:prstGeom prst="rect">
+            <a:avLst/>
+          </a:prstGeom>
+          <a:noFill/>
+        </p:spPr>
+        <p:txBody>
+          <a:bodyPr wrap="square" anchor="t" lIns="0" rIns="0" tIns="0" bIns="0">
+            <a:spAutoFit/>
+          </a:bodyPr>
+          <a:lstStyle/>
+          <a:p>
+            <a:pPr algn="r">
+              <a:lnSpc>
+                <a:spcPct val="100000"/>
+              </a:lnSpc>
+              <a:spcBef>
+                <a:spcPts val="0"/>
+              </a:spcBef>
+              <a:spcAft>
+                <a:spcPts val="600"/>
+              </a:spcAft>
+            </a:pPr>
+            <a:r>
+              <a:rPr sz="1000" b="0">
+                <a:solidFill>
+                  <a:srgbClr val="93A0B5"/>
+                </a:solidFill>
+                <a:latin typeface="Segoe UI"/>
+              </a:rPr>
+              <a:t>10 / 10</a:t>
+            </a:r>
+          </a:p>
+        </p:txBody>
+      </p:sp>
+      <p:sp>
+        <p:nvSpPr>
+          <p:cNvPr id="24" name="TextBox 23"/>
           <p:cNvSpPr txBox="1"/>
           <p:nvPr/>
         </p:nvSpPr>
@@ -3930,8 +5611,8 @@
         </p:nvSpPr>
         <p:spPr>
           <a:xfrm>
-            <a:off x="10698480" y="6419088"/>
-            <a:ext cx="1371600" cy="274320"/>
+            <a:off x="10515600" y="6419088"/>
+            <a:ext cx="1554480" cy="274320"/>
           </a:xfrm>
           <a:prstGeom prst="rect">
             <a:avLst/>
@@ -3962,7 +5643,7 @@
                 </a:solidFill>
                 <a:latin typeface="Segoe UI"/>
               </a:rPr>
-              <a:t>2 / 7</a:t>
+              <a:t>2 / 10</a:t>
             </a:r>
           </a:p>
         </p:txBody>
@@ -4416,8 +6097,8 @@
         </p:nvSpPr>
         <p:spPr>
           <a:xfrm>
-            <a:off x="10698480" y="6419088"/>
-            <a:ext cx="1371600" cy="274320"/>
+            <a:off x="10515600" y="6419088"/>
+            <a:ext cx="1554480" cy="274320"/>
           </a:xfrm>
           <a:prstGeom prst="rect">
             <a:avLst/>
@@ -4448,7 +6129,7 @@
                 </a:solidFill>
                 <a:latin typeface="Segoe UI"/>
               </a:rPr>
-              <a:t>3 / 7</a:t>
+              <a:t>3 / 10</a:t>
             </a:r>
           </a:p>
         </p:txBody>
@@ -4902,8 +6583,8 @@
         </p:nvSpPr>
         <p:spPr>
           <a:xfrm>
-            <a:off x="10698480" y="6419088"/>
-            <a:ext cx="1371600" cy="274320"/>
+            <a:off x="10515600" y="6419088"/>
+            <a:ext cx="1554480" cy="274320"/>
           </a:xfrm>
           <a:prstGeom prst="rect">
             <a:avLst/>
@@ -4934,7 +6615,7 @@
                 </a:solidFill>
                 <a:latin typeface="Segoe UI"/>
               </a:rPr>
-              <a:t>4 / 7</a:t>
+              <a:t>4 / 10</a:t>
             </a:r>
           </a:p>
         </p:txBody>
@@ -5388,8 +7069,8 @@
         </p:nvSpPr>
         <p:spPr>
           <a:xfrm>
-            <a:off x="10698480" y="6419088"/>
-            <a:ext cx="1371600" cy="274320"/>
+            <a:off x="10515600" y="6419088"/>
+            <a:ext cx="1554480" cy="274320"/>
           </a:xfrm>
           <a:prstGeom prst="rect">
             <a:avLst/>
@@ -5420,7 +7101,7 @@
                 </a:solidFill>
                 <a:latin typeface="Segoe UI"/>
               </a:rPr>
-              <a:t>5 / 7</a:t>
+              <a:t>5 / 10</a:t>
             </a:r>
           </a:p>
         </p:txBody>
@@ -5874,8 +7555,8 @@
         </p:nvSpPr>
         <p:spPr>
           <a:xfrm>
-            <a:off x="10698480" y="6419088"/>
-            <a:ext cx="1371600" cy="274320"/>
+            <a:off x="10515600" y="6419088"/>
+            <a:ext cx="1554480" cy="274320"/>
           </a:xfrm>
           <a:prstGeom prst="rect">
             <a:avLst/>
@@ -5906,7 +7587,7 @@
                 </a:solidFill>
                 <a:latin typeface="Segoe UI"/>
               </a:rPr>
-              <a:t>6 / 7</a:t>
+              <a:t>6 / 10</a:t>
             </a:r>
           </a:p>
         </p:txBody>
@@ -6022,7 +7703,7 @@
                 </a:solidFill>
                 <a:latin typeface="Segoe UI"/>
               </a:rPr>
-              <a:t>FAZIT</a:t>
+              <a:t>MEHR FUNKTIONEN</a:t>
             </a:r>
           </a:p>
         </p:txBody>
@@ -6036,7 +7717,7 @@
         <p:spPr>
           <a:xfrm>
             <a:off x="548640" y="1024128"/>
-            <a:ext cx="10972800" cy="914400"/>
+            <a:ext cx="11064240" cy="822960"/>
           </a:xfrm>
           <a:prstGeom prst="rect">
             <a:avLst/>
@@ -6061,13 +7742,13 @@
               </a:spcAft>
             </a:pPr>
             <a:r>
-              <a:rPr sz="3400" b="1">
+              <a:rPr sz="3300" b="1">
                 <a:solidFill>
                   <a:srgbClr val="F2F5FA"/>
                 </a:solidFill>
                 <a:latin typeface="Segoe UI"/>
               </a:rPr>
-              <a:t>Warum das überzeugt</a:t>
+              <a:t>Und da steckt noch mehr drin</a:t>
             </a:r>
           </a:p>
         </p:txBody>
@@ -6080,8 +7761,8 @@
         </p:nvSpPr>
         <p:spPr>
           <a:xfrm>
-            <a:off x="548640" y="2148840"/>
-            <a:ext cx="5349240" cy="1783080"/>
+            <a:off x="548640" y="1600200"/>
+            <a:ext cx="3474720" cy="3154680"/>
           </a:xfrm>
           <a:prstGeom prst="roundRect">
             <a:avLst/>
@@ -6118,16 +7799,45 @@
           </a:p>
         </p:txBody>
       </p:sp>
-      <p:sp>
-        <p:nvSpPr>
-          <p:cNvPr id="5" name="TextBox 4"/>
+      <p:pic>
+        <p:nvPicPr>
+          <p:cNvPr id="5" name="Picture 4" descr="07_vlan.png"/>
+          <p:cNvPicPr>
+            <a:picLocks noChangeAspect="1"/>
+          </p:cNvPicPr>
+          <p:nvPr/>
+        </p:nvPicPr>
+        <p:blipFill>
+          <a:blip r:embed="rId2"/>
+          <a:stretch>
+            <a:fillRect/>
+          </a:stretch>
+        </p:blipFill>
+        <p:spPr>
+          <a:xfrm>
+            <a:off x="658368" y="2315852"/>
+            <a:ext cx="3255264" cy="1723375"/>
+          </a:xfrm>
+          <a:prstGeom prst="rect">
+            <a:avLst/>
+          </a:prstGeom>
+          <a:ln w="15875">
+            <a:solidFill>
+              <a:srgbClr val="2A3652"/>
+            </a:solidFill>
+          </a:ln>
+        </p:spPr>
+      </p:pic>
+      <p:sp>
+        <p:nvSpPr>
+          <p:cNvPr id="6" name="TextBox 5"/>
           <p:cNvSpPr txBox="1"/>
           <p:nvPr/>
         </p:nvSpPr>
         <p:spPr>
           <a:xfrm>
-            <a:off x="841247" y="2350008"/>
-            <a:ext cx="4846320" cy="365760"/>
+            <a:off x="594360" y="4882896"/>
+            <a:ext cx="3429000" cy="365760"/>
           </a:xfrm>
           <a:prstGeom prst="rect">
             <a:avLst/>
@@ -6152,27 +7862,27 @@
               </a:spcAft>
             </a:pPr>
             <a:r>
-              <a:rPr sz="1600" b="1">
-                <a:solidFill>
-                  <a:srgbClr val="7C83FF"/>
-                </a:solidFill>
-                <a:latin typeface="Segoe UI"/>
-              </a:rPr>
-              <a:t>Betrieb &amp; Kosten</a:t>
-            </a:r>
-          </a:p>
-        </p:txBody>
-      </p:sp>
-      <p:sp>
-        <p:nvSpPr>
-          <p:cNvPr id="6" name="TextBox 5"/>
+              <a:rPr sz="1400" b="1">
+                <a:solidFill>
+                  <a:srgbClr val="F2F5FA"/>
+                </a:solidFill>
+                <a:latin typeface="Segoe UI"/>
+              </a:rPr>
+              <a:t>VLAN-/Netzwerk-Suche</a:t>
+            </a:r>
+          </a:p>
+        </p:txBody>
+      </p:sp>
+      <p:sp>
+        <p:nvSpPr>
+          <p:cNvPr id="7" name="TextBox 6"/>
           <p:cNvSpPr txBox="1"/>
           <p:nvPr/>
         </p:nvSpPr>
         <p:spPr>
           <a:xfrm>
-            <a:off x="841247" y="2807208"/>
-            <a:ext cx="4800600" cy="1005840"/>
+            <a:off x="594360" y="5230368"/>
+            <a:ext cx="3429000" cy="640080"/>
           </a:xfrm>
           <a:prstGeom prst="rect">
             <a:avLst/>
@@ -6187,77 +7897,37 @@
           <a:p>
             <a:pPr algn="l">
               <a:lnSpc>
-                <a:spcPct val="103000"/>
-              </a:lnSpc>
-              <a:spcBef>
-                <a:spcPts val="0"/>
-              </a:spcBef>
-              <a:spcAft>
-                <a:spcPts val="700"/>
-              </a:spcAft>
-            </a:pPr>
-            <a:r>
-              <a:rPr sz="1400" b="1">
-                <a:solidFill>
-                  <a:srgbClr val="7C83FF"/>
-                </a:solidFill>
-                <a:latin typeface="Segoe UI"/>
-              </a:rPr>
-              <a:t>▸  </a:t>
-            </a:r>
-            <a:r>
-              <a:rPr sz="1400" b="0">
-                <a:solidFill>
-                  <a:srgbClr val="F2F5FA"/>
-                </a:solidFill>
-                <a:latin typeface="Segoe UI"/>
-              </a:rPr>
-              <a:t>Eine einzige Python-Datei — kein Build, keine Datenbank, keine Fremd-Pakete</a:t>
-            </a:r>
-          </a:p>
-          <a:p>
-            <a:pPr algn="l">
-              <a:lnSpc>
-                <a:spcPct val="103000"/>
-              </a:lnSpc>
-              <a:spcBef>
-                <a:spcPts val="0"/>
-              </a:spcBef>
-              <a:spcAft>
-                <a:spcPts val="700"/>
-              </a:spcAft>
-            </a:pPr>
-            <a:r>
-              <a:rPr sz="1400" b="1">
-                <a:solidFill>
-                  <a:srgbClr val="7C83FF"/>
-                </a:solidFill>
-                <a:latin typeface="Segoe UI"/>
-              </a:rPr>
-              <a:t>▸  </a:t>
-            </a:r>
-            <a:r>
-              <a:rPr sz="1400" b="0">
-                <a:solidFill>
-                  <a:srgbClr val="F2F5FA"/>
-                </a:solidFill>
-                <a:latin typeface="Segoe UI"/>
-              </a:rPr>
-              <a:t>Läuft auf jedem RHEL-Host; ein Update = eine Datei austauschen</a:t>
-            </a:r>
-          </a:p>
-        </p:txBody>
-      </p:sp>
-      <p:sp>
-        <p:nvSpPr>
-          <p:cNvPr id="7" name="Rounded Rectangle 6"/>
+                <a:spcPct val="102000"/>
+              </a:lnSpc>
+              <a:spcBef>
+                <a:spcPts val="0"/>
+              </a:spcBef>
+              <a:spcAft>
+                <a:spcPts val="600"/>
+              </a:spcAft>
+            </a:pPr>
+            <a:r>
+              <a:rPr sz="1150" b="0">
+                <a:solidFill>
+                  <a:srgbClr val="93A0B5"/>
+                </a:solidFill>
+                <a:latin typeface="Segoe UI"/>
+              </a:rPr>
+              <a:t>Portgruppen &amp; VLANs clusterübergreifend finden</a:t>
+            </a:r>
+          </a:p>
+        </p:txBody>
+      </p:sp>
+      <p:sp>
+        <p:nvSpPr>
+          <p:cNvPr id="8" name="Rounded Rectangle 7"/>
           <p:cNvSpPr/>
           <p:nvPr/>
         </p:nvSpPr>
         <p:spPr>
           <a:xfrm>
-            <a:off x="6309360" y="2148840"/>
-            <a:ext cx="5349240" cy="1783080"/>
+            <a:off x="4352544" y="1600200"/>
+            <a:ext cx="3474720" cy="3154680"/>
           </a:xfrm>
           <a:prstGeom prst="roundRect">
             <a:avLst/>
@@ -6294,16 +7964,45 @@
           </a:p>
         </p:txBody>
       </p:sp>
-      <p:sp>
-        <p:nvSpPr>
-          <p:cNvPr id="8" name="TextBox 7"/>
+      <p:pic>
+        <p:nvPicPr>
+          <p:cNvPr id="9" name="Picture 8" descr="08_verwaltung.png"/>
+          <p:cNvPicPr>
+            <a:picLocks noChangeAspect="1"/>
+          </p:cNvPicPr>
+          <p:nvPr/>
+        </p:nvPicPr>
+        <p:blipFill>
+          <a:blip r:embed="rId3"/>
+          <a:stretch>
+            <a:fillRect/>
+          </a:stretch>
+        </p:blipFill>
+        <p:spPr>
+          <a:xfrm>
+            <a:off x="4462272" y="2267981"/>
+            <a:ext cx="3255264" cy="1819118"/>
+          </a:xfrm>
+          <a:prstGeom prst="rect">
+            <a:avLst/>
+          </a:prstGeom>
+          <a:ln w="15875">
+            <a:solidFill>
+              <a:srgbClr val="2A3652"/>
+            </a:solidFill>
+          </a:ln>
+        </p:spPr>
+      </p:pic>
+      <p:sp>
+        <p:nvSpPr>
+          <p:cNvPr id="10" name="TextBox 9"/>
           <p:cNvSpPr txBox="1"/>
           <p:nvPr/>
         </p:nvSpPr>
         <p:spPr>
           <a:xfrm>
-            <a:off x="6601968" y="2350008"/>
-            <a:ext cx="4846320" cy="365760"/>
+            <a:off x="4398264" y="4882896"/>
+            <a:ext cx="3429000" cy="365760"/>
           </a:xfrm>
           <a:prstGeom prst="rect">
             <a:avLst/>
@@ -6328,27 +8027,27 @@
               </a:spcAft>
             </a:pPr>
             <a:r>
-              <a:rPr sz="1600" b="1">
-                <a:solidFill>
-                  <a:srgbClr val="7C83FF"/>
-                </a:solidFill>
-                <a:latin typeface="Segoe UI"/>
-              </a:rPr>
-              <a:t>Sicherheit &amp; Compliance</a:t>
-            </a:r>
-          </a:p>
-        </p:txBody>
-      </p:sp>
-      <p:sp>
-        <p:nvSpPr>
-          <p:cNvPr id="9" name="TextBox 8"/>
+              <a:rPr sz="1400" b="1">
+                <a:solidFill>
+                  <a:srgbClr val="F2F5FA"/>
+                </a:solidFill>
+                <a:latin typeface="Segoe UI"/>
+              </a:rPr>
+              <a:t>Rollen, AD-Gruppen &amp; Sichtbarkeit</a:t>
+            </a:r>
+          </a:p>
+        </p:txBody>
+      </p:sp>
+      <p:sp>
+        <p:nvSpPr>
+          <p:cNvPr id="11" name="TextBox 10"/>
           <p:cNvSpPr txBox="1"/>
           <p:nvPr/>
         </p:nvSpPr>
         <p:spPr>
           <a:xfrm>
-            <a:off x="6601968" y="2807208"/>
-            <a:ext cx="4800600" cy="1005840"/>
+            <a:off x="4398264" y="5230368"/>
+            <a:ext cx="3429000" cy="640080"/>
           </a:xfrm>
           <a:prstGeom prst="rect">
             <a:avLst/>
@@ -6363,77 +8062,37 @@
           <a:p>
             <a:pPr algn="l">
               <a:lnSpc>
-                <a:spcPct val="103000"/>
-              </a:lnSpc>
-              <a:spcBef>
-                <a:spcPts val="0"/>
-              </a:spcBef>
-              <a:spcAft>
-                <a:spcPts val="700"/>
-              </a:spcAft>
-            </a:pPr>
-            <a:r>
-              <a:rPr sz="1400" b="1">
-                <a:solidFill>
-                  <a:srgbClr val="7C83FF"/>
-                </a:solidFill>
-                <a:latin typeface="Segoe UI"/>
-              </a:rPr>
-              <a:t>▸  </a:t>
-            </a:r>
-            <a:r>
-              <a:rPr sz="1400" b="0">
-                <a:solidFill>
-                  <a:srgbClr val="F2F5FA"/>
-                </a:solidFill>
-                <a:latin typeface="Segoe UI"/>
-              </a:rPr>
-              <a:t>AD-Anmeldung, rollenbasierte Sichtbarkeit, quellenbezogene Filter</a:t>
-            </a:r>
-          </a:p>
-          <a:p>
-            <a:pPr algn="l">
-              <a:lnSpc>
-                <a:spcPct val="103000"/>
-              </a:lnSpc>
-              <a:spcBef>
-                <a:spcPts val="0"/>
-              </a:spcBef>
-              <a:spcAft>
-                <a:spcPts val="700"/>
-              </a:spcAft>
-            </a:pPr>
-            <a:r>
-              <a:rPr sz="1400" b="1">
-                <a:solidFill>
-                  <a:srgbClr val="7C83FF"/>
-                </a:solidFill>
-                <a:latin typeface="Segoe UI"/>
-              </a:rPr>
-              <a:t>▸  </a:t>
-            </a:r>
-            <a:r>
-              <a:rPr sz="1400" b="0">
-                <a:solidFill>
-                  <a:srgbClr val="F2F5FA"/>
-                </a:solidFill>
-                <a:latin typeface="Segoe UI"/>
-              </a:rPr>
-              <a:t>5 unabhängige Security-Scanner in der CI, geschützter main-Branch</a:t>
-            </a:r>
-          </a:p>
-        </p:txBody>
-      </p:sp>
-      <p:sp>
-        <p:nvSpPr>
-          <p:cNvPr id="10" name="Rounded Rectangle 9"/>
+                <a:spcPct val="102000"/>
+              </a:lnSpc>
+              <a:spcBef>
+                <a:spcPts val="0"/>
+              </a:spcBef>
+              <a:spcAft>
+                <a:spcPts val="600"/>
+              </a:spcAft>
+            </a:pPr>
+            <a:r>
+              <a:rPr sz="1150" b="0">
+                <a:solidFill>
+                  <a:srgbClr val="93A0B5"/>
+                </a:solidFill>
+                <a:latin typeface="Segoe UI"/>
+              </a:rPr>
+              <a:t>feingranular steuerbar, quellenbezogen filterbar</a:t>
+            </a:r>
+          </a:p>
+        </p:txBody>
+      </p:sp>
+      <p:sp>
+        <p:nvSpPr>
+          <p:cNvPr id="12" name="Rounded Rectangle 11"/>
           <p:cNvSpPr/>
           <p:nvPr/>
         </p:nvSpPr>
         <p:spPr>
           <a:xfrm>
-            <a:off x="548640" y="4160520"/>
-            <a:ext cx="5349240" cy="1783080"/>
+            <a:off x="8156448" y="1600200"/>
+            <a:ext cx="3474720" cy="3154680"/>
           </a:xfrm>
           <a:prstGeom prst="roundRect">
             <a:avLst/>
@@ -6470,16 +8129,45 @@
           </a:p>
         </p:txBody>
       </p:sp>
-      <p:sp>
-        <p:nvSpPr>
-          <p:cNvPr id="11" name="TextBox 10"/>
+      <p:pic>
+        <p:nvPicPr>
+          <p:cNvPr id="13" name="Picture 12" descr="09_apidocs.png"/>
+          <p:cNvPicPr>
+            <a:picLocks noChangeAspect="1"/>
+          </p:cNvPicPr>
+          <p:nvPr/>
+        </p:nvPicPr>
+        <p:blipFill>
+          <a:blip r:embed="rId4"/>
+          <a:stretch>
+            <a:fillRect/>
+          </a:stretch>
+        </p:blipFill>
+        <p:spPr>
+          <a:xfrm>
+            <a:off x="8266175" y="2148302"/>
+            <a:ext cx="3255264" cy="2058475"/>
+          </a:xfrm>
+          <a:prstGeom prst="rect">
+            <a:avLst/>
+          </a:prstGeom>
+          <a:ln w="15875">
+            <a:solidFill>
+              <a:srgbClr val="2A3652"/>
+            </a:solidFill>
+          </a:ln>
+        </p:spPr>
+      </p:pic>
+      <p:sp>
+        <p:nvSpPr>
+          <p:cNvPr id="14" name="TextBox 13"/>
           <p:cNvSpPr txBox="1"/>
           <p:nvPr/>
         </p:nvSpPr>
         <p:spPr>
           <a:xfrm>
-            <a:off x="841247" y="4361688"/>
-            <a:ext cx="4846320" cy="365760"/>
+            <a:off x="8202168" y="4882896"/>
+            <a:ext cx="3429000" cy="365760"/>
           </a:xfrm>
           <a:prstGeom prst="rect">
             <a:avLst/>
@@ -6504,27 +8192,27 @@
               </a:spcAft>
             </a:pPr>
             <a:r>
-              <a:rPr sz="1600" b="1">
-                <a:solidFill>
-                  <a:srgbClr val="7C83FF"/>
-                </a:solidFill>
-                <a:latin typeface="Segoe UI"/>
-              </a:rPr>
-              <a:t>Reichweite</a:t>
-            </a:r>
-          </a:p>
-        </p:txBody>
-      </p:sp>
-      <p:sp>
-        <p:nvSpPr>
-          <p:cNvPr id="12" name="TextBox 11"/>
+              <a:rPr sz="1400" b="1">
+                <a:solidFill>
+                  <a:srgbClr val="F2F5FA"/>
+                </a:solidFill>
+                <a:latin typeface="Segoe UI"/>
+              </a:rPr>
+              <a:t>Eingebaute REST-API</a:t>
+            </a:r>
+          </a:p>
+        </p:txBody>
+      </p:sp>
+      <p:sp>
+        <p:nvSpPr>
+          <p:cNvPr id="15" name="TextBox 14"/>
           <p:cNvSpPr txBox="1"/>
           <p:nvPr/>
         </p:nvSpPr>
         <p:spPr>
           <a:xfrm>
-            <a:off x="841247" y="4818888"/>
-            <a:ext cx="4800600" cy="1005840"/>
+            <a:off x="8202168" y="5230368"/>
+            <a:ext cx="3429000" cy="640080"/>
           </a:xfrm>
           <a:prstGeom prst="rect">
             <a:avLst/>
@@ -6539,77 +8227,386 @@
           <a:p>
             <a:pPr algn="l">
               <a:lnSpc>
-                <a:spcPct val="103000"/>
-              </a:lnSpc>
-              <a:spcBef>
-                <a:spcPts val="0"/>
-              </a:spcBef>
-              <a:spcAft>
-                <a:spcPts val="700"/>
-              </a:spcAft>
-            </a:pPr>
-            <a:r>
-              <a:rPr sz="1400" b="1">
+                <a:spcPct val="102000"/>
+              </a:lnSpc>
+              <a:spcBef>
+                <a:spcPts val="0"/>
+              </a:spcBef>
+              <a:spcAft>
+                <a:spcPts val="600"/>
+              </a:spcAft>
+            </a:pPr>
+            <a:r>
+              <a:rPr sz="1150" b="0">
+                <a:solidFill>
+                  <a:srgbClr val="93A0B5"/>
+                </a:solidFill>
+                <a:latin typeface="Segoe UI"/>
+              </a:rPr>
+              <a:t>für Grafana, CMDB &amp; Automatisierung</a:t>
+            </a:r>
+          </a:p>
+        </p:txBody>
+      </p:sp>
+      <p:sp>
+        <p:nvSpPr>
+          <p:cNvPr id="16" name="TextBox 15"/>
+          <p:cNvSpPr txBox="1"/>
+          <p:nvPr/>
+        </p:nvSpPr>
+        <p:spPr>
+          <a:xfrm>
+            <a:off x="548640" y="6144768"/>
+            <a:ext cx="11064240" cy="457200"/>
+          </a:xfrm>
+          <a:prstGeom prst="rect">
+            <a:avLst/>
+          </a:prstGeom>
+          <a:noFill/>
+        </p:spPr>
+        <p:txBody>
+          <a:bodyPr wrap="square" anchor="t" lIns="0" rIns="0" tIns="0" bIns="0">
+            <a:spAutoFit/>
+          </a:bodyPr>
+          <a:lstStyle/>
+          <a:p>
+            <a:pPr algn="l">
+              <a:lnSpc>
+                <a:spcPct val="105000"/>
+              </a:lnSpc>
+              <a:spcBef>
+                <a:spcPts val="0"/>
+              </a:spcBef>
+              <a:spcAft>
+                <a:spcPts val="600"/>
+              </a:spcAft>
+            </a:pPr>
+            <a:r>
+              <a:rPr sz="1250" b="1">
                 <a:solidFill>
                   <a:srgbClr val="7C83FF"/>
                 </a:solidFill>
                 <a:latin typeface="Segoe UI"/>
               </a:rPr>
-              <a:t>▸  </a:t>
-            </a:r>
-            <a:r>
-              <a:rPr sz="1400" b="0">
+              <a:t>Außerdem: </a:t>
+            </a:r>
+            <a:r>
+              <a:rPr sz="1250" b="0">
+                <a:solidFill>
+                  <a:srgbClr val="93A0B5"/>
+                </a:solidFill>
+                <a:latin typeface="Segoe UI"/>
+              </a:rPr>
+              <a:t>Hell-/Dunkel-Modus · SFTP-Backup · Mail-Benachrichtigungen &amp; Erinnerungen · CSV-Import/Export · Auto-Freigabe · Reviewer-Handbuch · Ankündigungen · konfigurierbare Zeitzone · seitenweises Blättern</a:t>
+            </a:r>
+          </a:p>
+        </p:txBody>
+      </p:sp>
+      <p:sp>
+        <p:nvSpPr>
+          <p:cNvPr id="17" name="Rectangle 16"/>
+          <p:cNvSpPr/>
+          <p:nvPr/>
+        </p:nvSpPr>
+        <p:spPr>
+          <a:xfrm>
+            <a:off x="0" y="6729984"/>
+            <a:ext cx="12191695" cy="128016"/>
+          </a:xfrm>
+          <a:prstGeom prst="rect">
+            <a:avLst/>
+          </a:prstGeom>
+          <a:solidFill>
+            <a:srgbClr val="7C83FF"/>
+          </a:solidFill>
+          <a:ln>
+            <a:noFill/>
+          </a:ln>
+          <a:effectLst/>
+        </p:spPr>
+        <p:style>
+          <a:lnRef idx="1">
+            <a:schemeClr val="accent1"/>
+          </a:lnRef>
+          <a:fillRef idx="3">
+            <a:schemeClr val="accent1"/>
+          </a:fillRef>
+          <a:effectRef idx="2">
+            <a:schemeClr val="accent1"/>
+          </a:effectRef>
+          <a:fontRef idx="minor">
+            <a:schemeClr val="lt1"/>
+          </a:fontRef>
+        </p:style>
+        <p:txBody>
+          <a:bodyPr rtlCol="0" anchor="ctr"/>
+          <a:lstStyle/>
+          <a:p>
+            <a:pPr algn="ctr"/>
+          </a:p>
+        </p:txBody>
+      </p:sp>
+      <p:sp>
+        <p:nvSpPr>
+          <p:cNvPr id="18" name="TextBox 17"/>
+          <p:cNvSpPr txBox="1"/>
+          <p:nvPr/>
+        </p:nvSpPr>
+        <p:spPr>
+          <a:xfrm>
+            <a:off x="10515600" y="6419088"/>
+            <a:ext cx="1554480" cy="274320"/>
+          </a:xfrm>
+          <a:prstGeom prst="rect">
+            <a:avLst/>
+          </a:prstGeom>
+          <a:noFill/>
+        </p:spPr>
+        <p:txBody>
+          <a:bodyPr wrap="square" anchor="t" lIns="0" rIns="0" tIns="0" bIns="0">
+            <a:spAutoFit/>
+          </a:bodyPr>
+          <a:lstStyle/>
+          <a:p>
+            <a:pPr algn="r">
+              <a:lnSpc>
+                <a:spcPct val="100000"/>
+              </a:lnSpc>
+              <a:spcBef>
+                <a:spcPts val="0"/>
+              </a:spcBef>
+              <a:spcAft>
+                <a:spcPts val="600"/>
+              </a:spcAft>
+            </a:pPr>
+            <a:r>
+              <a:rPr sz="1000" b="0">
+                <a:solidFill>
+                  <a:srgbClr val="93A0B5"/>
+                </a:solidFill>
+                <a:latin typeface="Segoe UI"/>
+              </a:rPr>
+              <a:t>7 / 10</a:t>
+            </a:r>
+          </a:p>
+        </p:txBody>
+      </p:sp>
+      <p:sp>
+        <p:nvSpPr>
+          <p:cNvPr id="19" name="TextBox 18"/>
+          <p:cNvSpPr txBox="1"/>
+          <p:nvPr/>
+        </p:nvSpPr>
+        <p:spPr>
+          <a:xfrm>
+            <a:off x="502920" y="6419088"/>
+            <a:ext cx="7315200" cy="274320"/>
+          </a:xfrm>
+          <a:prstGeom prst="rect">
+            <a:avLst/>
+          </a:prstGeom>
+          <a:noFill/>
+        </p:spPr>
+        <p:txBody>
+          <a:bodyPr wrap="square" anchor="t" lIns="0" rIns="0" tIns="0" bIns="0">
+            <a:spAutoFit/>
+          </a:bodyPr>
+          <a:lstStyle/>
+          <a:p>
+            <a:pPr algn="l">
+              <a:lnSpc>
+                <a:spcPct val="100000"/>
+              </a:lnSpc>
+              <a:spcBef>
+                <a:spcPts val="0"/>
+              </a:spcBef>
+              <a:spcAft>
+                <a:spcPts val="600"/>
+              </a:spcAft>
+            </a:pPr>
+            <a:r>
+              <a:rPr sz="1000" b="0">
+                <a:solidFill>
+                  <a:srgbClr val="93A0B5"/>
+                </a:solidFill>
+                <a:latin typeface="Segoe UI"/>
+              </a:rPr>
+              <a:t>VMware Kapazitätsplanung</a:t>
+            </a:r>
+          </a:p>
+        </p:txBody>
+      </p:sp>
+    </p:spTree>
+  </p:cSld>
+  <p:clrMapOvr>
+    <a:masterClrMapping/>
+  </p:clrMapOvr>
+</p:sld>
+</file>
+
+<file path=ppt/slides/slide8.xml><?xml version="1.0" encoding="utf-8"?>
+<p:sld xmlns:a="http://schemas.openxmlformats.org/drawingml/2006/main" xmlns:p="http://schemas.openxmlformats.org/presentationml/2006/main" xmlns:r="http://schemas.openxmlformats.org/officeDocument/2006/relationships">
+  <p:cSld>
+    <p:bg>
+      <p:bgPr>
+        <a:solidFill>
+          <a:srgbClr val="0B1220"/>
+        </a:solidFill>
+        <a:effectLst/>
+      </p:bgPr>
+    </p:bg>
+    <p:spTree>
+      <p:nvGrpSpPr>
+        <p:cNvPr id="1" name=""/>
+        <p:cNvGrpSpPr/>
+        <p:nvPr/>
+      </p:nvGrpSpPr>
+      <p:grpSpPr/>
+      <p:sp>
+        <p:nvSpPr>
+          <p:cNvPr id="2" name="TextBox 1"/>
+          <p:cNvSpPr txBox="1"/>
+          <p:nvPr/>
+        </p:nvSpPr>
+        <p:spPr>
+          <a:xfrm>
+            <a:off x="548640" y="640080"/>
+            <a:ext cx="10972800" cy="365760"/>
+          </a:xfrm>
+          <a:prstGeom prst="rect">
+            <a:avLst/>
+          </a:prstGeom>
+          <a:noFill/>
+        </p:spPr>
+        <p:txBody>
+          <a:bodyPr wrap="square" anchor="t" lIns="0" rIns="0" tIns="0" bIns="0">
+            <a:spAutoFit/>
+          </a:bodyPr>
+          <a:lstStyle/>
+          <a:p>
+            <a:pPr algn="l">
+              <a:lnSpc>
+                <a:spcPct val="100000"/>
+              </a:lnSpc>
+              <a:spcBef>
+                <a:spcPts val="0"/>
+              </a:spcBef>
+              <a:spcAft>
+                <a:spcPts val="600"/>
+              </a:spcAft>
+            </a:pPr>
+            <a:r>
+              <a:rPr sz="1300" b="1">
+                <a:solidFill>
+                  <a:srgbClr val="7C83FF"/>
+                </a:solidFill>
+                <a:latin typeface="Segoe UI"/>
+              </a:rPr>
+              <a:t>ENTWICKLUNG</a:t>
+            </a:r>
+          </a:p>
+        </p:txBody>
+      </p:sp>
+      <p:sp>
+        <p:nvSpPr>
+          <p:cNvPr id="3" name="TextBox 2"/>
+          <p:cNvSpPr txBox="1"/>
+          <p:nvPr/>
+        </p:nvSpPr>
+        <p:spPr>
+          <a:xfrm>
+            <a:off x="548640" y="1024128"/>
+            <a:ext cx="11064240" cy="822960"/>
+          </a:xfrm>
+          <a:prstGeom prst="rect">
+            <a:avLst/>
+          </a:prstGeom>
+          <a:noFill/>
+        </p:spPr>
+        <p:txBody>
+          <a:bodyPr wrap="square" anchor="t" lIns="0" rIns="0" tIns="0" bIns="0">
+            <a:spAutoFit/>
+          </a:bodyPr>
+          <a:lstStyle/>
+          <a:p>
+            <a:pPr algn="l">
+              <a:lnSpc>
+                <a:spcPct val="100000"/>
+              </a:lnSpc>
+              <a:spcBef>
+                <a:spcPts val="0"/>
+              </a:spcBef>
+              <a:spcAft>
+                <a:spcPts val="600"/>
+              </a:spcAft>
+            </a:pPr>
+            <a:r>
+              <a:rPr sz="3300" b="1">
                 <a:solidFill>
                   <a:srgbClr val="F2F5FA"/>
                 </a:solidFill>
                 <a:latin typeface="Segoe UI"/>
               </a:rPr>
-              <a:t>Zweisprachig DE/EN, offline- und proxy-fähig</a:t>
-            </a:r>
-          </a:p>
+              <a:t>Das Projekt in Zahlen</a:t>
+            </a:r>
+          </a:p>
+        </p:txBody>
+      </p:sp>
+      <p:sp>
+        <p:nvSpPr>
+          <p:cNvPr id="4" name="TextBox 3"/>
+          <p:cNvSpPr txBox="1"/>
+          <p:nvPr/>
+        </p:nvSpPr>
+        <p:spPr>
+          <a:xfrm>
+            <a:off x="548640" y="1737360"/>
+            <a:ext cx="10972800" cy="457200"/>
+          </a:xfrm>
+          <a:prstGeom prst="rect">
+            <a:avLst/>
+          </a:prstGeom>
+          <a:noFill/>
+        </p:spPr>
+        <p:txBody>
+          <a:bodyPr wrap="square" anchor="t" lIns="0" rIns="0" tIns="0" bIns="0">
+            <a:spAutoFit/>
+          </a:bodyPr>
+          <a:lstStyle/>
           <a:p>
             <a:pPr algn="l">
               <a:lnSpc>
-                <a:spcPct val="103000"/>
-              </a:lnSpc>
-              <a:spcBef>
-                <a:spcPts val="0"/>
-              </a:spcBef>
-              <a:spcAft>
-                <a:spcPts val="700"/>
-              </a:spcAft>
-            </a:pPr>
-            <a:r>
-              <a:rPr sz="1400" b="1">
-                <a:solidFill>
-                  <a:srgbClr val="7C83FF"/>
-                </a:solidFill>
-                <a:latin typeface="Segoe UI"/>
-              </a:rPr>
-              <a:t>▸  </a:t>
-            </a:r>
-            <a:r>
-              <a:rPr sz="1400" b="0">
-                <a:solidFill>
-                  <a:srgbClr val="F2F5FA"/>
-                </a:solidFill>
-                <a:latin typeface="Segoe UI"/>
-              </a:rPr>
-              <a:t>Lesende API für Grafana, CMDB &amp; Co.</a:t>
-            </a:r>
-          </a:p>
-        </p:txBody>
-      </p:sp>
-      <p:sp>
-        <p:nvSpPr>
-          <p:cNvPr id="13" name="Rounded Rectangle 12"/>
+                <a:spcPct val="100000"/>
+              </a:lnSpc>
+              <a:spcBef>
+                <a:spcPts val="0"/>
+              </a:spcBef>
+              <a:spcAft>
+                <a:spcPts val="600"/>
+              </a:spcAft>
+            </a:pPr>
+            <a:r>
+              <a:rPr sz="1450" b="0">
+                <a:solidFill>
+                  <a:srgbClr val="93A0B5"/>
+                </a:solidFill>
+                <a:latin typeface="Segoe UI"/>
+              </a:rPr>
+              <a:t>Von der ersten Zeile bis heute — in rund zwei Wochen aktiver Entwicklung.</a:t>
+            </a:r>
+          </a:p>
+        </p:txBody>
+      </p:sp>
+      <p:sp>
+        <p:nvSpPr>
+          <p:cNvPr id="5" name="Rounded Rectangle 4"/>
           <p:cNvSpPr/>
           <p:nvPr/>
         </p:nvSpPr>
         <p:spPr>
           <a:xfrm>
-            <a:off x="6309360" y="4160520"/>
-            <a:ext cx="5349240" cy="1783080"/>
+            <a:off x="548640" y="2377440"/>
+            <a:ext cx="2560320" cy="1737360"/>
           </a:xfrm>
           <a:prstGeom prst="roundRect">
             <a:avLst/>
@@ -6648,14 +8645,14 @@
       </p:sp>
       <p:sp>
         <p:nvSpPr>
-          <p:cNvPr id="14" name="TextBox 13"/>
+          <p:cNvPr id="6" name="TextBox 5"/>
           <p:cNvSpPr txBox="1"/>
           <p:nvPr/>
         </p:nvSpPr>
         <p:spPr>
           <a:xfrm>
-            <a:off x="6601968" y="4361688"/>
-            <a:ext cx="4846320" cy="365760"/>
+            <a:off x="548640" y="2633472"/>
+            <a:ext cx="2560320" cy="868680"/>
           </a:xfrm>
           <a:prstGeom prst="rect">
             <a:avLst/>
@@ -6668,7 +8665,7 @@
           </a:bodyPr>
           <a:lstStyle/>
           <a:p>
-            <a:pPr algn="l">
+            <a:pPr algn="ctr">
               <a:lnSpc>
                 <a:spcPct val="100000"/>
               </a:lnSpc>
@@ -6680,27 +8677,27 @@
               </a:spcAft>
             </a:pPr>
             <a:r>
-              <a:rPr sz="1600" b="1">
+              <a:rPr sz="4000" b="1">
                 <a:solidFill>
                   <a:srgbClr val="7C83FF"/>
                 </a:solidFill>
                 <a:latin typeface="Segoe UI"/>
               </a:rPr>
-              <a:t>Pflege &amp; Reife</a:t>
-            </a:r>
-          </a:p>
-        </p:txBody>
-      </p:sp>
-      <p:sp>
-        <p:nvSpPr>
-          <p:cNvPr id="15" name="TextBox 14"/>
+              <a:t>105</a:t>
+            </a:r>
+          </a:p>
+        </p:txBody>
+      </p:sp>
+      <p:sp>
+        <p:nvSpPr>
+          <p:cNvPr id="7" name="TextBox 6"/>
           <p:cNvSpPr txBox="1"/>
           <p:nvPr/>
         </p:nvSpPr>
         <p:spPr>
           <a:xfrm>
-            <a:off x="6601968" y="4818888"/>
-            <a:ext cx="4800600" cy="1005840"/>
+            <a:off x="685800" y="3511296"/>
+            <a:ext cx="2286000" cy="548640"/>
           </a:xfrm>
           <a:prstGeom prst="rect">
             <a:avLst/>
@@ -6713,79 +8710,85 @@
           </a:bodyPr>
           <a:lstStyle/>
           <a:p>
-            <a:pPr algn="l">
-              <a:lnSpc>
-                <a:spcPct val="103000"/>
-              </a:lnSpc>
-              <a:spcBef>
-                <a:spcPts val="0"/>
-              </a:spcBef>
-              <a:spcAft>
-                <a:spcPts val="700"/>
-              </a:spcAft>
-            </a:pPr>
-            <a:r>
-              <a:rPr sz="1400" b="1">
-                <a:solidFill>
-                  <a:srgbClr val="7C83FF"/>
-                </a:solidFill>
-                <a:latin typeface="Segoe UI"/>
-              </a:rPr>
-              <a:t>▸  </a:t>
-            </a:r>
-            <a:r>
-              <a:rPr sz="1400" b="0">
-                <a:solidFill>
-                  <a:srgbClr val="F2F5FA"/>
-                </a:solidFill>
-                <a:latin typeface="Segoe UI"/>
-              </a:rPr>
-              <a:t>Aktiv weiterentwickelt — über 100 Releases</a:t>
-            </a:r>
-          </a:p>
-          <a:p>
-            <a:pPr algn="l">
-              <a:lnSpc>
-                <a:spcPct val="103000"/>
-              </a:lnSpc>
-              <a:spcBef>
-                <a:spcPts val="0"/>
-              </a:spcBef>
-              <a:spcAft>
-                <a:spcPts val="700"/>
-              </a:spcAft>
-            </a:pPr>
-            <a:r>
-              <a:rPr sz="1400" b="1">
-                <a:solidFill>
-                  <a:srgbClr val="7C83FF"/>
-                </a:solidFill>
-                <a:latin typeface="Segoe UI"/>
-              </a:rPr>
-              <a:t>▸  </a:t>
-            </a:r>
-            <a:r>
-              <a:rPr sz="1400" b="0">
-                <a:solidFill>
-                  <a:srgbClr val="F2F5FA"/>
-                </a:solidFill>
-                <a:latin typeface="Segoe UI"/>
-              </a:rPr>
-              <a:t>Reviewer-Handbuch, Architektur-Doku, Smoke-Tests inklusive</a:t>
-            </a:r>
-          </a:p>
-        </p:txBody>
-      </p:sp>
-      <p:sp>
-        <p:nvSpPr>
-          <p:cNvPr id="16" name="TextBox 15"/>
+            <a:pPr algn="ctr">
+              <a:lnSpc>
+                <a:spcPct val="100000"/>
+              </a:lnSpc>
+              <a:spcBef>
+                <a:spcPts val="0"/>
+              </a:spcBef>
+              <a:spcAft>
+                <a:spcPts val="600"/>
+              </a:spcAft>
+            </a:pPr>
+            <a:r>
+              <a:rPr sz="1200" b="0">
+                <a:solidFill>
+                  <a:srgbClr val="93A0B5"/>
+                </a:solidFill>
+                <a:latin typeface="Segoe UI"/>
+              </a:rPr>
+              <a:t>Releases</a:t>
+            </a:r>
+          </a:p>
+        </p:txBody>
+      </p:sp>
+      <p:sp>
+        <p:nvSpPr>
+          <p:cNvPr id="8" name="Rounded Rectangle 7"/>
+          <p:cNvSpPr/>
+          <p:nvPr/>
+        </p:nvSpPr>
+        <p:spPr>
+          <a:xfrm>
+            <a:off x="3392424" y="2377440"/>
+            <a:ext cx="2560320" cy="1737360"/>
+          </a:xfrm>
+          <a:prstGeom prst="roundRect">
+            <a:avLst/>
+          </a:prstGeom>
+          <a:solidFill>
+            <a:srgbClr val="151E33"/>
+          </a:solidFill>
+          <a:ln w="12700">
+            <a:solidFill>
+              <a:srgbClr val="2A3652"/>
+            </a:solidFill>
+          </a:ln>
+          <a:effectLst/>
+        </p:spPr>
+        <p:style>
+          <a:lnRef idx="1">
+            <a:schemeClr val="accent1"/>
+          </a:lnRef>
+          <a:fillRef idx="3">
+            <a:schemeClr val="accent1"/>
+          </a:fillRef>
+          <a:effectRef idx="2">
+            <a:schemeClr val="accent1"/>
+          </a:effectRef>
+          <a:fontRef idx="minor">
+            <a:schemeClr val="lt1"/>
+          </a:fontRef>
+        </p:style>
+        <p:txBody>
+          <a:bodyPr rtlCol="0" anchor="ctr"/>
+          <a:lstStyle/>
+          <a:p>
+            <a:pPr algn="ctr"/>
+          </a:p>
+        </p:txBody>
+      </p:sp>
+      <p:sp>
+        <p:nvSpPr>
+          <p:cNvPr id="9" name="TextBox 8"/>
           <p:cNvSpPr txBox="1"/>
           <p:nvPr/>
         </p:nvSpPr>
         <p:spPr>
           <a:xfrm>
-            <a:off x="548640" y="6144768"/>
-            <a:ext cx="10972800" cy="457200"/>
+            <a:off x="3392424" y="2633472"/>
+            <a:ext cx="2560320" cy="868680"/>
           </a:xfrm>
           <a:prstGeom prst="rect">
             <a:avLst/>
@@ -6798,7 +8801,7 @@
           </a:bodyPr>
           <a:lstStyle/>
           <a:p>
-            <a:pPr algn="l">
+            <a:pPr algn="ctr">
               <a:lnSpc>
                 <a:spcPct val="100000"/>
               </a:lnSpc>
@@ -6810,20 +8813,881 @@
               </a:spcAft>
             </a:pPr>
             <a:r>
-              <a:rPr sz="1600" b="1">
-                <a:solidFill>
-                  <a:srgbClr val="34D399"/>
-                </a:solidFill>
-                <a:latin typeface="Segoe UI"/>
-              </a:rPr>
-              <a:t>Wenig Angriffsfläche. Kein Vendor-Lock-in. Sofort einsatzbereit.</a:t>
-            </a:r>
-          </a:p>
-        </p:txBody>
-      </p:sp>
-      <p:sp>
-        <p:nvSpPr>
-          <p:cNvPr id="17" name="Rectangle 16"/>
+              <a:rPr sz="4000" b="1">
+                <a:solidFill>
+                  <a:srgbClr val="7C83FF"/>
+                </a:solidFill>
+                <a:latin typeface="Segoe UI"/>
+              </a:rPr>
+              <a:t>167</a:t>
+            </a:r>
+          </a:p>
+        </p:txBody>
+      </p:sp>
+      <p:sp>
+        <p:nvSpPr>
+          <p:cNvPr id="10" name="TextBox 9"/>
+          <p:cNvSpPr txBox="1"/>
+          <p:nvPr/>
+        </p:nvSpPr>
+        <p:spPr>
+          <a:xfrm>
+            <a:off x="3529584" y="3511296"/>
+            <a:ext cx="2286000" cy="548640"/>
+          </a:xfrm>
+          <a:prstGeom prst="rect">
+            <a:avLst/>
+          </a:prstGeom>
+          <a:noFill/>
+        </p:spPr>
+        <p:txBody>
+          <a:bodyPr wrap="square" anchor="t" lIns="0" rIns="0" tIns="0" bIns="0">
+            <a:spAutoFit/>
+          </a:bodyPr>
+          <a:lstStyle/>
+          <a:p>
+            <a:pPr algn="ctr">
+              <a:lnSpc>
+                <a:spcPct val="100000"/>
+              </a:lnSpc>
+              <a:spcBef>
+                <a:spcPts val="0"/>
+              </a:spcBef>
+              <a:spcAft>
+                <a:spcPts val="600"/>
+              </a:spcAft>
+            </a:pPr>
+            <a:r>
+              <a:rPr sz="1200" b="0">
+                <a:solidFill>
+                  <a:srgbClr val="93A0B5"/>
+                </a:solidFill>
+                <a:latin typeface="Segoe UI"/>
+              </a:rPr>
+              <a:t>Commits</a:t>
+            </a:r>
+          </a:p>
+        </p:txBody>
+      </p:sp>
+      <p:sp>
+        <p:nvSpPr>
+          <p:cNvPr id="11" name="Rounded Rectangle 10"/>
+          <p:cNvSpPr/>
+          <p:nvPr/>
+        </p:nvSpPr>
+        <p:spPr>
+          <a:xfrm>
+            <a:off x="6236207" y="2377440"/>
+            <a:ext cx="2560320" cy="1737360"/>
+          </a:xfrm>
+          <a:prstGeom prst="roundRect">
+            <a:avLst/>
+          </a:prstGeom>
+          <a:solidFill>
+            <a:srgbClr val="151E33"/>
+          </a:solidFill>
+          <a:ln w="12700">
+            <a:solidFill>
+              <a:srgbClr val="2A3652"/>
+            </a:solidFill>
+          </a:ln>
+          <a:effectLst/>
+        </p:spPr>
+        <p:style>
+          <a:lnRef idx="1">
+            <a:schemeClr val="accent1"/>
+          </a:lnRef>
+          <a:fillRef idx="3">
+            <a:schemeClr val="accent1"/>
+          </a:fillRef>
+          <a:effectRef idx="2">
+            <a:schemeClr val="accent1"/>
+          </a:effectRef>
+          <a:fontRef idx="minor">
+            <a:schemeClr val="lt1"/>
+          </a:fontRef>
+        </p:style>
+        <p:txBody>
+          <a:bodyPr rtlCol="0" anchor="ctr"/>
+          <a:lstStyle/>
+          <a:p>
+            <a:pPr algn="ctr"/>
+          </a:p>
+        </p:txBody>
+      </p:sp>
+      <p:sp>
+        <p:nvSpPr>
+          <p:cNvPr id="12" name="TextBox 11"/>
+          <p:cNvSpPr txBox="1"/>
+          <p:nvPr/>
+        </p:nvSpPr>
+        <p:spPr>
+          <a:xfrm>
+            <a:off x="6236207" y="2633472"/>
+            <a:ext cx="2560320" cy="868680"/>
+          </a:xfrm>
+          <a:prstGeom prst="rect">
+            <a:avLst/>
+          </a:prstGeom>
+          <a:noFill/>
+        </p:spPr>
+        <p:txBody>
+          <a:bodyPr wrap="square" anchor="t" lIns="0" rIns="0" tIns="0" bIns="0">
+            <a:spAutoFit/>
+          </a:bodyPr>
+          <a:lstStyle/>
+          <a:p>
+            <a:pPr algn="ctr">
+              <a:lnSpc>
+                <a:spcPct val="100000"/>
+              </a:lnSpc>
+              <a:spcBef>
+                <a:spcPts val="0"/>
+              </a:spcBef>
+              <a:spcAft>
+                <a:spcPts val="600"/>
+              </a:spcAft>
+            </a:pPr>
+            <a:r>
+              <a:rPr sz="4000" b="1">
+                <a:solidFill>
+                  <a:srgbClr val="7C83FF"/>
+                </a:solidFill>
+                <a:latin typeface="Segoe UI"/>
+              </a:rPr>
+              <a:t>11.114</a:t>
+            </a:r>
+          </a:p>
+        </p:txBody>
+      </p:sp>
+      <p:sp>
+        <p:nvSpPr>
+          <p:cNvPr id="13" name="TextBox 12"/>
+          <p:cNvSpPr txBox="1"/>
+          <p:nvPr/>
+        </p:nvSpPr>
+        <p:spPr>
+          <a:xfrm>
+            <a:off x="6373368" y="3511296"/>
+            <a:ext cx="2286000" cy="548640"/>
+          </a:xfrm>
+          <a:prstGeom prst="rect">
+            <a:avLst/>
+          </a:prstGeom>
+          <a:noFill/>
+        </p:spPr>
+        <p:txBody>
+          <a:bodyPr wrap="square" anchor="t" lIns="0" rIns="0" tIns="0" bIns="0">
+            <a:spAutoFit/>
+          </a:bodyPr>
+          <a:lstStyle/>
+          <a:p>
+            <a:pPr algn="ctr">
+              <a:lnSpc>
+                <a:spcPct val="100000"/>
+              </a:lnSpc>
+              <a:spcBef>
+                <a:spcPts val="0"/>
+              </a:spcBef>
+              <a:spcAft>
+                <a:spcPts val="600"/>
+              </a:spcAft>
+            </a:pPr>
+            <a:r>
+              <a:rPr sz="1200" b="0">
+                <a:solidFill>
+                  <a:srgbClr val="93A0B5"/>
+                </a:solidFill>
+                <a:latin typeface="Segoe UI"/>
+              </a:rPr>
+              <a:t>Zeilen Code · 1 Datei</a:t>
+            </a:r>
+          </a:p>
+        </p:txBody>
+      </p:sp>
+      <p:sp>
+        <p:nvSpPr>
+          <p:cNvPr id="14" name="Rounded Rectangle 13"/>
+          <p:cNvSpPr/>
+          <p:nvPr/>
+        </p:nvSpPr>
+        <p:spPr>
+          <a:xfrm>
+            <a:off x="9079992" y="2377440"/>
+            <a:ext cx="2560320" cy="1737360"/>
+          </a:xfrm>
+          <a:prstGeom prst="roundRect">
+            <a:avLst/>
+          </a:prstGeom>
+          <a:solidFill>
+            <a:srgbClr val="151E33"/>
+          </a:solidFill>
+          <a:ln w="12700">
+            <a:solidFill>
+              <a:srgbClr val="2A3652"/>
+            </a:solidFill>
+          </a:ln>
+          <a:effectLst/>
+        </p:spPr>
+        <p:style>
+          <a:lnRef idx="1">
+            <a:schemeClr val="accent1"/>
+          </a:lnRef>
+          <a:fillRef idx="3">
+            <a:schemeClr val="accent1"/>
+          </a:fillRef>
+          <a:effectRef idx="2">
+            <a:schemeClr val="accent1"/>
+          </a:effectRef>
+          <a:fontRef idx="minor">
+            <a:schemeClr val="lt1"/>
+          </a:fontRef>
+        </p:style>
+        <p:txBody>
+          <a:bodyPr rtlCol="0" anchor="ctr"/>
+          <a:lstStyle/>
+          <a:p>
+            <a:pPr algn="ctr"/>
+          </a:p>
+        </p:txBody>
+      </p:sp>
+      <p:sp>
+        <p:nvSpPr>
+          <p:cNvPr id="15" name="TextBox 14"/>
+          <p:cNvSpPr txBox="1"/>
+          <p:nvPr/>
+        </p:nvSpPr>
+        <p:spPr>
+          <a:xfrm>
+            <a:off x="9079992" y="2633472"/>
+            <a:ext cx="2560320" cy="868680"/>
+          </a:xfrm>
+          <a:prstGeom prst="rect">
+            <a:avLst/>
+          </a:prstGeom>
+          <a:noFill/>
+        </p:spPr>
+        <p:txBody>
+          <a:bodyPr wrap="square" anchor="t" lIns="0" rIns="0" tIns="0" bIns="0">
+            <a:spAutoFit/>
+          </a:bodyPr>
+          <a:lstStyle/>
+          <a:p>
+            <a:pPr algn="ctr">
+              <a:lnSpc>
+                <a:spcPct val="100000"/>
+              </a:lnSpc>
+              <a:spcBef>
+                <a:spcPts val="0"/>
+              </a:spcBef>
+              <a:spcAft>
+                <a:spcPts val="600"/>
+              </a:spcAft>
+            </a:pPr>
+            <a:r>
+              <a:rPr sz="4000" b="1">
+                <a:solidFill>
+                  <a:srgbClr val="7C83FF"/>
+                </a:solidFill>
+                <a:latin typeface="Segoe UI"/>
+              </a:rPr>
+              <a:t>0</a:t>
+            </a:r>
+          </a:p>
+        </p:txBody>
+      </p:sp>
+      <p:sp>
+        <p:nvSpPr>
+          <p:cNvPr id="16" name="TextBox 15"/>
+          <p:cNvSpPr txBox="1"/>
+          <p:nvPr/>
+        </p:nvSpPr>
+        <p:spPr>
+          <a:xfrm>
+            <a:off x="9217152" y="3511296"/>
+            <a:ext cx="2286000" cy="548640"/>
+          </a:xfrm>
+          <a:prstGeom prst="rect">
+            <a:avLst/>
+          </a:prstGeom>
+          <a:noFill/>
+        </p:spPr>
+        <p:txBody>
+          <a:bodyPr wrap="square" anchor="t" lIns="0" rIns="0" tIns="0" bIns="0">
+            <a:spAutoFit/>
+          </a:bodyPr>
+          <a:lstStyle/>
+          <a:p>
+            <a:pPr algn="ctr">
+              <a:lnSpc>
+                <a:spcPct val="100000"/>
+              </a:lnSpc>
+              <a:spcBef>
+                <a:spcPts val="0"/>
+              </a:spcBef>
+              <a:spcAft>
+                <a:spcPts val="600"/>
+              </a:spcAft>
+            </a:pPr>
+            <a:r>
+              <a:rPr sz="1200" b="0">
+                <a:solidFill>
+                  <a:srgbClr val="93A0B5"/>
+                </a:solidFill>
+                <a:latin typeface="Segoe UI"/>
+              </a:rPr>
+              <a:t>Fremd-Abhängigkeiten</a:t>
+            </a:r>
+          </a:p>
+        </p:txBody>
+      </p:sp>
+      <p:sp>
+        <p:nvSpPr>
+          <p:cNvPr id="17" name="Rounded Rectangle 16"/>
+          <p:cNvSpPr/>
+          <p:nvPr/>
+        </p:nvSpPr>
+        <p:spPr>
+          <a:xfrm>
+            <a:off x="548640" y="4251960"/>
+            <a:ext cx="2560320" cy="1737360"/>
+          </a:xfrm>
+          <a:prstGeom prst="roundRect">
+            <a:avLst/>
+          </a:prstGeom>
+          <a:solidFill>
+            <a:srgbClr val="151E33"/>
+          </a:solidFill>
+          <a:ln w="12700">
+            <a:solidFill>
+              <a:srgbClr val="2A3652"/>
+            </a:solidFill>
+          </a:ln>
+          <a:effectLst/>
+        </p:spPr>
+        <p:style>
+          <a:lnRef idx="1">
+            <a:schemeClr val="accent1"/>
+          </a:lnRef>
+          <a:fillRef idx="3">
+            <a:schemeClr val="accent1"/>
+          </a:fillRef>
+          <a:effectRef idx="2">
+            <a:schemeClr val="accent1"/>
+          </a:effectRef>
+          <a:fontRef idx="minor">
+            <a:schemeClr val="lt1"/>
+          </a:fontRef>
+        </p:style>
+        <p:txBody>
+          <a:bodyPr rtlCol="0" anchor="ctr"/>
+          <a:lstStyle/>
+          <a:p>
+            <a:pPr algn="ctr"/>
+          </a:p>
+        </p:txBody>
+      </p:sp>
+      <p:sp>
+        <p:nvSpPr>
+          <p:cNvPr id="18" name="TextBox 17"/>
+          <p:cNvSpPr txBox="1"/>
+          <p:nvPr/>
+        </p:nvSpPr>
+        <p:spPr>
+          <a:xfrm>
+            <a:off x="548640" y="4507992"/>
+            <a:ext cx="2560320" cy="868680"/>
+          </a:xfrm>
+          <a:prstGeom prst="rect">
+            <a:avLst/>
+          </a:prstGeom>
+          <a:noFill/>
+        </p:spPr>
+        <p:txBody>
+          <a:bodyPr wrap="square" anchor="t" lIns="0" rIns="0" tIns="0" bIns="0">
+            <a:spAutoFit/>
+          </a:bodyPr>
+          <a:lstStyle/>
+          <a:p>
+            <a:pPr algn="ctr">
+              <a:lnSpc>
+                <a:spcPct val="100000"/>
+              </a:lnSpc>
+              <a:spcBef>
+                <a:spcPts val="0"/>
+              </a:spcBef>
+              <a:spcAft>
+                <a:spcPts val="600"/>
+              </a:spcAft>
+            </a:pPr>
+            <a:r>
+              <a:rPr sz="4000" b="1">
+                <a:solidFill>
+                  <a:srgbClr val="7C83FF"/>
+                </a:solidFill>
+                <a:latin typeface="Segoe UI"/>
+              </a:rPr>
+              <a:t>94</a:t>
+            </a:r>
+          </a:p>
+        </p:txBody>
+      </p:sp>
+      <p:sp>
+        <p:nvSpPr>
+          <p:cNvPr id="19" name="TextBox 18"/>
+          <p:cNvSpPr txBox="1"/>
+          <p:nvPr/>
+        </p:nvSpPr>
+        <p:spPr>
+          <a:xfrm>
+            <a:off x="685800" y="5385816"/>
+            <a:ext cx="2286000" cy="548640"/>
+          </a:xfrm>
+          <a:prstGeom prst="rect">
+            <a:avLst/>
+          </a:prstGeom>
+          <a:noFill/>
+        </p:spPr>
+        <p:txBody>
+          <a:bodyPr wrap="square" anchor="t" lIns="0" rIns="0" tIns="0" bIns="0">
+            <a:spAutoFit/>
+          </a:bodyPr>
+          <a:lstStyle/>
+          <a:p>
+            <a:pPr algn="ctr">
+              <a:lnSpc>
+                <a:spcPct val="100000"/>
+              </a:lnSpc>
+              <a:spcBef>
+                <a:spcPts val="0"/>
+              </a:spcBef>
+              <a:spcAft>
+                <a:spcPts val="600"/>
+              </a:spcAft>
+            </a:pPr>
+            <a:r>
+              <a:rPr sz="1200" b="0">
+                <a:solidFill>
+                  <a:srgbClr val="93A0B5"/>
+                </a:solidFill>
+                <a:latin typeface="Segoe UI"/>
+              </a:rPr>
+              <a:t>automatisierte Smoke-Checks</a:t>
+            </a:r>
+          </a:p>
+        </p:txBody>
+      </p:sp>
+      <p:sp>
+        <p:nvSpPr>
+          <p:cNvPr id="20" name="Rounded Rectangle 19"/>
+          <p:cNvSpPr/>
+          <p:nvPr/>
+        </p:nvSpPr>
+        <p:spPr>
+          <a:xfrm>
+            <a:off x="3392424" y="4251960"/>
+            <a:ext cx="2560320" cy="1737360"/>
+          </a:xfrm>
+          <a:prstGeom prst="roundRect">
+            <a:avLst/>
+          </a:prstGeom>
+          <a:solidFill>
+            <a:srgbClr val="151E33"/>
+          </a:solidFill>
+          <a:ln w="12700">
+            <a:solidFill>
+              <a:srgbClr val="2A3652"/>
+            </a:solidFill>
+          </a:ln>
+          <a:effectLst/>
+        </p:spPr>
+        <p:style>
+          <a:lnRef idx="1">
+            <a:schemeClr val="accent1"/>
+          </a:lnRef>
+          <a:fillRef idx="3">
+            <a:schemeClr val="accent1"/>
+          </a:fillRef>
+          <a:effectRef idx="2">
+            <a:schemeClr val="accent1"/>
+          </a:effectRef>
+          <a:fontRef idx="minor">
+            <a:schemeClr val="lt1"/>
+          </a:fontRef>
+        </p:style>
+        <p:txBody>
+          <a:bodyPr rtlCol="0" anchor="ctr"/>
+          <a:lstStyle/>
+          <a:p>
+            <a:pPr algn="ctr"/>
+          </a:p>
+        </p:txBody>
+      </p:sp>
+      <p:sp>
+        <p:nvSpPr>
+          <p:cNvPr id="21" name="TextBox 20"/>
+          <p:cNvSpPr txBox="1"/>
+          <p:nvPr/>
+        </p:nvSpPr>
+        <p:spPr>
+          <a:xfrm>
+            <a:off x="3392424" y="4507992"/>
+            <a:ext cx="2560320" cy="868680"/>
+          </a:xfrm>
+          <a:prstGeom prst="rect">
+            <a:avLst/>
+          </a:prstGeom>
+          <a:noFill/>
+        </p:spPr>
+        <p:txBody>
+          <a:bodyPr wrap="square" anchor="t" lIns="0" rIns="0" tIns="0" bIns="0">
+            <a:spAutoFit/>
+          </a:bodyPr>
+          <a:lstStyle/>
+          <a:p>
+            <a:pPr algn="ctr">
+              <a:lnSpc>
+                <a:spcPct val="100000"/>
+              </a:lnSpc>
+              <a:spcBef>
+                <a:spcPts val="0"/>
+              </a:spcBef>
+              <a:spcAft>
+                <a:spcPts val="600"/>
+              </a:spcAft>
+            </a:pPr>
+            <a:r>
+              <a:rPr sz="4000" b="1">
+                <a:solidFill>
+                  <a:srgbClr val="7C83FF"/>
+                </a:solidFill>
+                <a:latin typeface="Segoe UI"/>
+              </a:rPr>
+              <a:t>5</a:t>
+            </a:r>
+          </a:p>
+        </p:txBody>
+      </p:sp>
+      <p:sp>
+        <p:nvSpPr>
+          <p:cNvPr id="22" name="TextBox 21"/>
+          <p:cNvSpPr txBox="1"/>
+          <p:nvPr/>
+        </p:nvSpPr>
+        <p:spPr>
+          <a:xfrm>
+            <a:off x="3529584" y="5385816"/>
+            <a:ext cx="2286000" cy="548640"/>
+          </a:xfrm>
+          <a:prstGeom prst="rect">
+            <a:avLst/>
+          </a:prstGeom>
+          <a:noFill/>
+        </p:spPr>
+        <p:txBody>
+          <a:bodyPr wrap="square" anchor="t" lIns="0" rIns="0" tIns="0" bIns="0">
+            <a:spAutoFit/>
+          </a:bodyPr>
+          <a:lstStyle/>
+          <a:p>
+            <a:pPr algn="ctr">
+              <a:lnSpc>
+                <a:spcPct val="100000"/>
+              </a:lnSpc>
+              <a:spcBef>
+                <a:spcPts val="0"/>
+              </a:spcBef>
+              <a:spcAft>
+                <a:spcPts val="600"/>
+              </a:spcAft>
+            </a:pPr>
+            <a:r>
+              <a:rPr sz="1200" b="0">
+                <a:solidFill>
+                  <a:srgbClr val="93A0B5"/>
+                </a:solidFill>
+                <a:latin typeface="Segoe UI"/>
+              </a:rPr>
+              <a:t>Security-Scanner in der CI</a:t>
+            </a:r>
+          </a:p>
+        </p:txBody>
+      </p:sp>
+      <p:sp>
+        <p:nvSpPr>
+          <p:cNvPr id="23" name="Rounded Rectangle 22"/>
+          <p:cNvSpPr/>
+          <p:nvPr/>
+        </p:nvSpPr>
+        <p:spPr>
+          <a:xfrm>
+            <a:off x="6236207" y="4251960"/>
+            <a:ext cx="2560320" cy="1737360"/>
+          </a:xfrm>
+          <a:prstGeom prst="roundRect">
+            <a:avLst/>
+          </a:prstGeom>
+          <a:solidFill>
+            <a:srgbClr val="151E33"/>
+          </a:solidFill>
+          <a:ln w="12700">
+            <a:solidFill>
+              <a:srgbClr val="2A3652"/>
+            </a:solidFill>
+          </a:ln>
+          <a:effectLst/>
+        </p:spPr>
+        <p:style>
+          <a:lnRef idx="1">
+            <a:schemeClr val="accent1"/>
+          </a:lnRef>
+          <a:fillRef idx="3">
+            <a:schemeClr val="accent1"/>
+          </a:fillRef>
+          <a:effectRef idx="2">
+            <a:schemeClr val="accent1"/>
+          </a:effectRef>
+          <a:fontRef idx="minor">
+            <a:schemeClr val="lt1"/>
+          </a:fontRef>
+        </p:style>
+        <p:txBody>
+          <a:bodyPr rtlCol="0" anchor="ctr"/>
+          <a:lstStyle/>
+          <a:p>
+            <a:pPr algn="ctr"/>
+          </a:p>
+        </p:txBody>
+      </p:sp>
+      <p:sp>
+        <p:nvSpPr>
+          <p:cNvPr id="24" name="TextBox 23"/>
+          <p:cNvSpPr txBox="1"/>
+          <p:nvPr/>
+        </p:nvSpPr>
+        <p:spPr>
+          <a:xfrm>
+            <a:off x="6236207" y="4507992"/>
+            <a:ext cx="2560320" cy="868680"/>
+          </a:xfrm>
+          <a:prstGeom prst="rect">
+            <a:avLst/>
+          </a:prstGeom>
+          <a:noFill/>
+        </p:spPr>
+        <p:txBody>
+          <a:bodyPr wrap="square" anchor="t" lIns="0" rIns="0" tIns="0" bIns="0">
+            <a:spAutoFit/>
+          </a:bodyPr>
+          <a:lstStyle/>
+          <a:p>
+            <a:pPr algn="ctr">
+              <a:lnSpc>
+                <a:spcPct val="100000"/>
+              </a:lnSpc>
+              <a:spcBef>
+                <a:spcPts val="0"/>
+              </a:spcBef>
+              <a:spcAft>
+                <a:spcPts val="600"/>
+              </a:spcAft>
+            </a:pPr>
+            <a:r>
+              <a:rPr sz="4000" b="1">
+                <a:solidFill>
+                  <a:srgbClr val="7C83FF"/>
+                </a:solidFill>
+                <a:latin typeface="Segoe UI"/>
+              </a:rPr>
+              <a:t>620+</a:t>
+            </a:r>
+          </a:p>
+        </p:txBody>
+      </p:sp>
+      <p:sp>
+        <p:nvSpPr>
+          <p:cNvPr id="25" name="TextBox 24"/>
+          <p:cNvSpPr txBox="1"/>
+          <p:nvPr/>
+        </p:nvSpPr>
+        <p:spPr>
+          <a:xfrm>
+            <a:off x="6373368" y="5385816"/>
+            <a:ext cx="2286000" cy="548640"/>
+          </a:xfrm>
+          <a:prstGeom prst="rect">
+            <a:avLst/>
+          </a:prstGeom>
+          <a:noFill/>
+        </p:spPr>
+        <p:txBody>
+          <a:bodyPr wrap="square" anchor="t" lIns="0" rIns="0" tIns="0" bIns="0">
+            <a:spAutoFit/>
+          </a:bodyPr>
+          <a:lstStyle/>
+          <a:p>
+            <a:pPr algn="ctr">
+              <a:lnSpc>
+                <a:spcPct val="100000"/>
+              </a:lnSpc>
+              <a:spcBef>
+                <a:spcPts val="0"/>
+              </a:spcBef>
+              <a:spcAft>
+                <a:spcPts val="600"/>
+              </a:spcAft>
+            </a:pPr>
+            <a:r>
+              <a:rPr sz="1200" b="0">
+                <a:solidFill>
+                  <a:srgbClr val="93A0B5"/>
+                </a:solidFill>
+                <a:latin typeface="Segoe UI"/>
+              </a:rPr>
+              <a:t>Übersetzungen · DE ↔ EN</a:t>
+            </a:r>
+          </a:p>
+        </p:txBody>
+      </p:sp>
+      <p:sp>
+        <p:nvSpPr>
+          <p:cNvPr id="26" name="Rounded Rectangle 25"/>
+          <p:cNvSpPr/>
+          <p:nvPr/>
+        </p:nvSpPr>
+        <p:spPr>
+          <a:xfrm>
+            <a:off x="9079992" y="4251960"/>
+            <a:ext cx="2560320" cy="1737360"/>
+          </a:xfrm>
+          <a:prstGeom prst="roundRect">
+            <a:avLst/>
+          </a:prstGeom>
+          <a:solidFill>
+            <a:srgbClr val="151E33"/>
+          </a:solidFill>
+          <a:ln w="12700">
+            <a:solidFill>
+              <a:srgbClr val="2A3652"/>
+            </a:solidFill>
+          </a:ln>
+          <a:effectLst/>
+        </p:spPr>
+        <p:style>
+          <a:lnRef idx="1">
+            <a:schemeClr val="accent1"/>
+          </a:lnRef>
+          <a:fillRef idx="3">
+            <a:schemeClr val="accent1"/>
+          </a:fillRef>
+          <a:effectRef idx="2">
+            <a:schemeClr val="accent1"/>
+          </a:effectRef>
+          <a:fontRef idx="minor">
+            <a:schemeClr val="lt1"/>
+          </a:fontRef>
+        </p:style>
+        <p:txBody>
+          <a:bodyPr rtlCol="0" anchor="ctr"/>
+          <a:lstStyle/>
+          <a:p>
+            <a:pPr algn="ctr"/>
+          </a:p>
+        </p:txBody>
+      </p:sp>
+      <p:sp>
+        <p:nvSpPr>
+          <p:cNvPr id="27" name="TextBox 26"/>
+          <p:cNvSpPr txBox="1"/>
+          <p:nvPr/>
+        </p:nvSpPr>
+        <p:spPr>
+          <a:xfrm>
+            <a:off x="9079992" y="4507992"/>
+            <a:ext cx="2560320" cy="868680"/>
+          </a:xfrm>
+          <a:prstGeom prst="rect">
+            <a:avLst/>
+          </a:prstGeom>
+          <a:noFill/>
+        </p:spPr>
+        <p:txBody>
+          <a:bodyPr wrap="square" anchor="t" lIns="0" rIns="0" tIns="0" bIns="0">
+            <a:spAutoFit/>
+          </a:bodyPr>
+          <a:lstStyle/>
+          <a:p>
+            <a:pPr algn="ctr">
+              <a:lnSpc>
+                <a:spcPct val="100000"/>
+              </a:lnSpc>
+              <a:spcBef>
+                <a:spcPts val="0"/>
+              </a:spcBef>
+              <a:spcAft>
+                <a:spcPts val="600"/>
+              </a:spcAft>
+            </a:pPr>
+            <a:r>
+              <a:rPr sz="4000" b="1">
+                <a:solidFill>
+                  <a:srgbClr val="7C83FF"/>
+                </a:solidFill>
+                <a:latin typeface="Segoe UI"/>
+              </a:rPr>
+              <a:t>11</a:t>
+            </a:r>
+          </a:p>
+        </p:txBody>
+      </p:sp>
+      <p:sp>
+        <p:nvSpPr>
+          <p:cNvPr id="28" name="TextBox 27"/>
+          <p:cNvSpPr txBox="1"/>
+          <p:nvPr/>
+        </p:nvSpPr>
+        <p:spPr>
+          <a:xfrm>
+            <a:off x="9217152" y="5385816"/>
+            <a:ext cx="2286000" cy="548640"/>
+          </a:xfrm>
+          <a:prstGeom prst="rect">
+            <a:avLst/>
+          </a:prstGeom>
+          <a:noFill/>
+        </p:spPr>
+        <p:txBody>
+          <a:bodyPr wrap="square" anchor="t" lIns="0" rIns="0" tIns="0" bIns="0">
+            <a:spAutoFit/>
+          </a:bodyPr>
+          <a:lstStyle/>
+          <a:p>
+            <a:pPr algn="ctr">
+              <a:lnSpc>
+                <a:spcPct val="100000"/>
+              </a:lnSpc>
+              <a:spcBef>
+                <a:spcPts val="0"/>
+              </a:spcBef>
+              <a:spcAft>
+                <a:spcPts val="600"/>
+              </a:spcAft>
+            </a:pPr>
+            <a:r>
+              <a:rPr sz="1200" b="0">
+                <a:solidFill>
+                  <a:srgbClr val="93A0B5"/>
+                </a:solidFill>
+                <a:latin typeface="Segoe UI"/>
+              </a:rPr>
+              <a:t>Verwaltungs-Bereiche</a:t>
+            </a:r>
+          </a:p>
+        </p:txBody>
+      </p:sp>
+      <p:sp>
+        <p:nvSpPr>
+          <p:cNvPr id="29" name="Rectangle 28"/>
           <p:cNvSpPr/>
           <p:nvPr/>
         </p:nvSpPr>
@@ -6867,14 +9731,14 @@
       </p:sp>
       <p:sp>
         <p:nvSpPr>
-          <p:cNvPr id="18" name="TextBox 17"/>
+          <p:cNvPr id="30" name="TextBox 29"/>
           <p:cNvSpPr txBox="1"/>
           <p:nvPr/>
         </p:nvSpPr>
         <p:spPr>
           <a:xfrm>
-            <a:off x="10698480" y="6419088"/>
-            <a:ext cx="1371600" cy="274320"/>
+            <a:off x="10515600" y="6419088"/>
+            <a:ext cx="1554480" cy="274320"/>
           </a:xfrm>
           <a:prstGeom prst="rect">
             <a:avLst/>
@@ -6905,7 +9769,1006 @@
                 </a:solidFill>
                 <a:latin typeface="Segoe UI"/>
               </a:rPr>
-              <a:t>7 / 7</a:t>
+              <a:t>8 / 10</a:t>
+            </a:r>
+          </a:p>
+        </p:txBody>
+      </p:sp>
+      <p:sp>
+        <p:nvSpPr>
+          <p:cNvPr id="31" name="TextBox 30"/>
+          <p:cNvSpPr txBox="1"/>
+          <p:nvPr/>
+        </p:nvSpPr>
+        <p:spPr>
+          <a:xfrm>
+            <a:off x="502920" y="6419088"/>
+            <a:ext cx="7315200" cy="274320"/>
+          </a:xfrm>
+          <a:prstGeom prst="rect">
+            <a:avLst/>
+          </a:prstGeom>
+          <a:noFill/>
+        </p:spPr>
+        <p:txBody>
+          <a:bodyPr wrap="square" anchor="t" lIns="0" rIns="0" tIns="0" bIns="0">
+            <a:spAutoFit/>
+          </a:bodyPr>
+          <a:lstStyle/>
+          <a:p>
+            <a:pPr algn="l">
+              <a:lnSpc>
+                <a:spcPct val="100000"/>
+              </a:lnSpc>
+              <a:spcBef>
+                <a:spcPts val="0"/>
+              </a:spcBef>
+              <a:spcAft>
+                <a:spcPts val="600"/>
+              </a:spcAft>
+            </a:pPr>
+            <a:r>
+              <a:rPr sz="1000" b="0">
+                <a:solidFill>
+                  <a:srgbClr val="93A0B5"/>
+                </a:solidFill>
+                <a:latin typeface="Segoe UI"/>
+              </a:rPr>
+              <a:t>VMware Kapazitätsplanung</a:t>
+            </a:r>
+          </a:p>
+        </p:txBody>
+      </p:sp>
+    </p:spTree>
+  </p:cSld>
+  <p:clrMapOvr>
+    <a:masterClrMapping/>
+  </p:clrMapOvr>
+</p:sld>
+</file>
+
+<file path=ppt/slides/slide9.xml><?xml version="1.0" encoding="utf-8"?>
+<p:sld xmlns:a="http://schemas.openxmlformats.org/drawingml/2006/main" xmlns:p="http://schemas.openxmlformats.org/presentationml/2006/main" xmlns:r="http://schemas.openxmlformats.org/officeDocument/2006/relationships">
+  <p:cSld>
+    <p:bg>
+      <p:bgPr>
+        <a:solidFill>
+          <a:srgbClr val="0B1220"/>
+        </a:solidFill>
+        <a:effectLst/>
+      </p:bgPr>
+    </p:bg>
+    <p:spTree>
+      <p:nvGrpSpPr>
+        <p:cNvPr id="1" name=""/>
+        <p:cNvGrpSpPr/>
+        <p:nvPr/>
+      </p:nvGrpSpPr>
+      <p:grpSpPr/>
+      <p:sp>
+        <p:nvSpPr>
+          <p:cNvPr id="2" name="TextBox 1"/>
+          <p:cNvSpPr txBox="1"/>
+          <p:nvPr/>
+        </p:nvSpPr>
+        <p:spPr>
+          <a:xfrm>
+            <a:off x="548640" y="640080"/>
+            <a:ext cx="10972800" cy="365760"/>
+          </a:xfrm>
+          <a:prstGeom prst="rect">
+            <a:avLst/>
+          </a:prstGeom>
+          <a:noFill/>
+        </p:spPr>
+        <p:txBody>
+          <a:bodyPr wrap="square" anchor="t" lIns="0" rIns="0" tIns="0" bIns="0">
+            <a:spAutoFit/>
+          </a:bodyPr>
+          <a:lstStyle/>
+          <a:p>
+            <a:pPr algn="l">
+              <a:lnSpc>
+                <a:spcPct val="100000"/>
+              </a:lnSpc>
+              <a:spcBef>
+                <a:spcPts val="0"/>
+              </a:spcBef>
+              <a:spcAft>
+                <a:spcPts val="600"/>
+              </a:spcAft>
+            </a:pPr>
+            <a:r>
+              <a:rPr sz="1300" b="1">
+                <a:solidFill>
+                  <a:srgbClr val="7C83FF"/>
+                </a:solidFill>
+                <a:latin typeface="Segoe UI"/>
+              </a:rPr>
+              <a:t>FAZIT</a:t>
+            </a:r>
+          </a:p>
+        </p:txBody>
+      </p:sp>
+      <p:sp>
+        <p:nvSpPr>
+          <p:cNvPr id="3" name="TextBox 2"/>
+          <p:cNvSpPr txBox="1"/>
+          <p:nvPr/>
+        </p:nvSpPr>
+        <p:spPr>
+          <a:xfrm>
+            <a:off x="548640" y="1024128"/>
+            <a:ext cx="11064240" cy="822960"/>
+          </a:xfrm>
+          <a:prstGeom prst="rect">
+            <a:avLst/>
+          </a:prstGeom>
+          <a:noFill/>
+        </p:spPr>
+        <p:txBody>
+          <a:bodyPr wrap="square" anchor="t" lIns="0" rIns="0" tIns="0" bIns="0">
+            <a:spAutoFit/>
+          </a:bodyPr>
+          <a:lstStyle/>
+          <a:p>
+            <a:pPr algn="l">
+              <a:lnSpc>
+                <a:spcPct val="100000"/>
+              </a:lnSpc>
+              <a:spcBef>
+                <a:spcPts val="0"/>
+              </a:spcBef>
+              <a:spcAft>
+                <a:spcPts val="600"/>
+              </a:spcAft>
+            </a:pPr>
+            <a:r>
+              <a:rPr sz="3300" b="1">
+                <a:solidFill>
+                  <a:srgbClr val="F2F5FA"/>
+                </a:solidFill>
+                <a:latin typeface="Segoe UI"/>
+              </a:rPr>
+              <a:t>Warum das überzeugt</a:t>
+            </a:r>
+          </a:p>
+        </p:txBody>
+      </p:sp>
+      <p:sp>
+        <p:nvSpPr>
+          <p:cNvPr id="4" name="Rounded Rectangle 3"/>
+          <p:cNvSpPr/>
+          <p:nvPr/>
+        </p:nvSpPr>
+        <p:spPr>
+          <a:xfrm>
+            <a:off x="548640" y="2148840"/>
+            <a:ext cx="5349240" cy="1783080"/>
+          </a:xfrm>
+          <a:prstGeom prst="roundRect">
+            <a:avLst/>
+          </a:prstGeom>
+          <a:solidFill>
+            <a:srgbClr val="151E33"/>
+          </a:solidFill>
+          <a:ln w="12700">
+            <a:solidFill>
+              <a:srgbClr val="2A3652"/>
+            </a:solidFill>
+          </a:ln>
+          <a:effectLst/>
+        </p:spPr>
+        <p:style>
+          <a:lnRef idx="1">
+            <a:schemeClr val="accent1"/>
+          </a:lnRef>
+          <a:fillRef idx="3">
+            <a:schemeClr val="accent1"/>
+          </a:fillRef>
+          <a:effectRef idx="2">
+            <a:schemeClr val="accent1"/>
+          </a:effectRef>
+          <a:fontRef idx="minor">
+            <a:schemeClr val="lt1"/>
+          </a:fontRef>
+        </p:style>
+        <p:txBody>
+          <a:bodyPr rtlCol="0" anchor="ctr"/>
+          <a:lstStyle/>
+          <a:p>
+            <a:pPr algn="ctr"/>
+          </a:p>
+        </p:txBody>
+      </p:sp>
+      <p:sp>
+        <p:nvSpPr>
+          <p:cNvPr id="5" name="TextBox 4"/>
+          <p:cNvSpPr txBox="1"/>
+          <p:nvPr/>
+        </p:nvSpPr>
+        <p:spPr>
+          <a:xfrm>
+            <a:off x="841247" y="2350008"/>
+            <a:ext cx="4846320" cy="365760"/>
+          </a:xfrm>
+          <a:prstGeom prst="rect">
+            <a:avLst/>
+          </a:prstGeom>
+          <a:noFill/>
+        </p:spPr>
+        <p:txBody>
+          <a:bodyPr wrap="square" anchor="t" lIns="0" rIns="0" tIns="0" bIns="0">
+            <a:spAutoFit/>
+          </a:bodyPr>
+          <a:lstStyle/>
+          <a:p>
+            <a:pPr algn="l">
+              <a:lnSpc>
+                <a:spcPct val="100000"/>
+              </a:lnSpc>
+              <a:spcBef>
+                <a:spcPts val="0"/>
+              </a:spcBef>
+              <a:spcAft>
+                <a:spcPts val="600"/>
+              </a:spcAft>
+            </a:pPr>
+            <a:r>
+              <a:rPr sz="1600" b="1">
+                <a:solidFill>
+                  <a:srgbClr val="7C83FF"/>
+                </a:solidFill>
+                <a:latin typeface="Segoe UI"/>
+              </a:rPr>
+              <a:t>Betrieb &amp; Kosten</a:t>
+            </a:r>
+          </a:p>
+        </p:txBody>
+      </p:sp>
+      <p:sp>
+        <p:nvSpPr>
+          <p:cNvPr id="6" name="TextBox 5"/>
+          <p:cNvSpPr txBox="1"/>
+          <p:nvPr/>
+        </p:nvSpPr>
+        <p:spPr>
+          <a:xfrm>
+            <a:off x="841247" y="2807208"/>
+            <a:ext cx="4800600" cy="1005840"/>
+          </a:xfrm>
+          <a:prstGeom prst="rect">
+            <a:avLst/>
+          </a:prstGeom>
+          <a:noFill/>
+        </p:spPr>
+        <p:txBody>
+          <a:bodyPr wrap="square" anchor="t" lIns="0" rIns="0" tIns="0" bIns="0">
+            <a:spAutoFit/>
+          </a:bodyPr>
+          <a:lstStyle/>
+          <a:p>
+            <a:pPr algn="l">
+              <a:lnSpc>
+                <a:spcPct val="103000"/>
+              </a:lnSpc>
+              <a:spcBef>
+                <a:spcPts val="0"/>
+              </a:spcBef>
+              <a:spcAft>
+                <a:spcPts val="700"/>
+              </a:spcAft>
+            </a:pPr>
+            <a:r>
+              <a:rPr sz="1400" b="1">
+                <a:solidFill>
+                  <a:srgbClr val="7C83FF"/>
+                </a:solidFill>
+                <a:latin typeface="Segoe UI"/>
+              </a:rPr>
+              <a:t>▸  </a:t>
+            </a:r>
+            <a:r>
+              <a:rPr sz="1400" b="0">
+                <a:solidFill>
+                  <a:srgbClr val="F2F5FA"/>
+                </a:solidFill>
+                <a:latin typeface="Segoe UI"/>
+              </a:rPr>
+              <a:t>Eine einzige Python-Datei — kein Build, keine Datenbank, keine Fremd-Pakete</a:t>
+            </a:r>
+          </a:p>
+          <a:p>
+            <a:pPr algn="l">
+              <a:lnSpc>
+                <a:spcPct val="103000"/>
+              </a:lnSpc>
+              <a:spcBef>
+                <a:spcPts val="0"/>
+              </a:spcBef>
+              <a:spcAft>
+                <a:spcPts val="700"/>
+              </a:spcAft>
+            </a:pPr>
+            <a:r>
+              <a:rPr sz="1400" b="1">
+                <a:solidFill>
+                  <a:srgbClr val="7C83FF"/>
+                </a:solidFill>
+                <a:latin typeface="Segoe UI"/>
+              </a:rPr>
+              <a:t>▸  </a:t>
+            </a:r>
+            <a:r>
+              <a:rPr sz="1400" b="0">
+                <a:solidFill>
+                  <a:srgbClr val="F2F5FA"/>
+                </a:solidFill>
+                <a:latin typeface="Segoe UI"/>
+              </a:rPr>
+              <a:t>Läuft auf jedem RHEL-Host; ein Update = eine Datei austauschen</a:t>
+            </a:r>
+          </a:p>
+        </p:txBody>
+      </p:sp>
+      <p:sp>
+        <p:nvSpPr>
+          <p:cNvPr id="7" name="Rounded Rectangle 6"/>
+          <p:cNvSpPr/>
+          <p:nvPr/>
+        </p:nvSpPr>
+        <p:spPr>
+          <a:xfrm>
+            <a:off x="6309360" y="2148840"/>
+            <a:ext cx="5349240" cy="1783080"/>
+          </a:xfrm>
+          <a:prstGeom prst="roundRect">
+            <a:avLst/>
+          </a:prstGeom>
+          <a:solidFill>
+            <a:srgbClr val="151E33"/>
+          </a:solidFill>
+          <a:ln w="12700">
+            <a:solidFill>
+              <a:srgbClr val="2A3652"/>
+            </a:solidFill>
+          </a:ln>
+          <a:effectLst/>
+        </p:spPr>
+        <p:style>
+          <a:lnRef idx="1">
+            <a:schemeClr val="accent1"/>
+          </a:lnRef>
+          <a:fillRef idx="3">
+            <a:schemeClr val="accent1"/>
+          </a:fillRef>
+          <a:effectRef idx="2">
+            <a:schemeClr val="accent1"/>
+          </a:effectRef>
+          <a:fontRef idx="minor">
+            <a:schemeClr val="lt1"/>
+          </a:fontRef>
+        </p:style>
+        <p:txBody>
+          <a:bodyPr rtlCol="0" anchor="ctr"/>
+          <a:lstStyle/>
+          <a:p>
+            <a:pPr algn="ctr"/>
+          </a:p>
+        </p:txBody>
+      </p:sp>
+      <p:sp>
+        <p:nvSpPr>
+          <p:cNvPr id="8" name="TextBox 7"/>
+          <p:cNvSpPr txBox="1"/>
+          <p:nvPr/>
+        </p:nvSpPr>
+        <p:spPr>
+          <a:xfrm>
+            <a:off x="6601968" y="2350008"/>
+            <a:ext cx="4846320" cy="365760"/>
+          </a:xfrm>
+          <a:prstGeom prst="rect">
+            <a:avLst/>
+          </a:prstGeom>
+          <a:noFill/>
+        </p:spPr>
+        <p:txBody>
+          <a:bodyPr wrap="square" anchor="t" lIns="0" rIns="0" tIns="0" bIns="0">
+            <a:spAutoFit/>
+          </a:bodyPr>
+          <a:lstStyle/>
+          <a:p>
+            <a:pPr algn="l">
+              <a:lnSpc>
+                <a:spcPct val="100000"/>
+              </a:lnSpc>
+              <a:spcBef>
+                <a:spcPts val="0"/>
+              </a:spcBef>
+              <a:spcAft>
+                <a:spcPts val="600"/>
+              </a:spcAft>
+            </a:pPr>
+            <a:r>
+              <a:rPr sz="1600" b="1">
+                <a:solidFill>
+                  <a:srgbClr val="7C83FF"/>
+                </a:solidFill>
+                <a:latin typeface="Segoe UI"/>
+              </a:rPr>
+              <a:t>Sicherheit &amp; Compliance</a:t>
+            </a:r>
+          </a:p>
+        </p:txBody>
+      </p:sp>
+      <p:sp>
+        <p:nvSpPr>
+          <p:cNvPr id="9" name="TextBox 8"/>
+          <p:cNvSpPr txBox="1"/>
+          <p:nvPr/>
+        </p:nvSpPr>
+        <p:spPr>
+          <a:xfrm>
+            <a:off x="6601968" y="2807208"/>
+            <a:ext cx="4800600" cy="1005840"/>
+          </a:xfrm>
+          <a:prstGeom prst="rect">
+            <a:avLst/>
+          </a:prstGeom>
+          <a:noFill/>
+        </p:spPr>
+        <p:txBody>
+          <a:bodyPr wrap="square" anchor="t" lIns="0" rIns="0" tIns="0" bIns="0">
+            <a:spAutoFit/>
+          </a:bodyPr>
+          <a:lstStyle/>
+          <a:p>
+            <a:pPr algn="l">
+              <a:lnSpc>
+                <a:spcPct val="103000"/>
+              </a:lnSpc>
+              <a:spcBef>
+                <a:spcPts val="0"/>
+              </a:spcBef>
+              <a:spcAft>
+                <a:spcPts val="700"/>
+              </a:spcAft>
+            </a:pPr>
+            <a:r>
+              <a:rPr sz="1400" b="1">
+                <a:solidFill>
+                  <a:srgbClr val="7C83FF"/>
+                </a:solidFill>
+                <a:latin typeface="Segoe UI"/>
+              </a:rPr>
+              <a:t>▸  </a:t>
+            </a:r>
+            <a:r>
+              <a:rPr sz="1400" b="0">
+                <a:solidFill>
+                  <a:srgbClr val="F2F5FA"/>
+                </a:solidFill>
+                <a:latin typeface="Segoe UI"/>
+              </a:rPr>
+              <a:t>AD-Anmeldung, rollenbasierte Sichtbarkeit, quellenbezogene Filter</a:t>
+            </a:r>
+          </a:p>
+          <a:p>
+            <a:pPr algn="l">
+              <a:lnSpc>
+                <a:spcPct val="103000"/>
+              </a:lnSpc>
+              <a:spcBef>
+                <a:spcPts val="0"/>
+              </a:spcBef>
+              <a:spcAft>
+                <a:spcPts val="700"/>
+              </a:spcAft>
+            </a:pPr>
+            <a:r>
+              <a:rPr sz="1400" b="1">
+                <a:solidFill>
+                  <a:srgbClr val="7C83FF"/>
+                </a:solidFill>
+                <a:latin typeface="Segoe UI"/>
+              </a:rPr>
+              <a:t>▸  </a:t>
+            </a:r>
+            <a:r>
+              <a:rPr sz="1400" b="0">
+                <a:solidFill>
+                  <a:srgbClr val="F2F5FA"/>
+                </a:solidFill>
+                <a:latin typeface="Segoe UI"/>
+              </a:rPr>
+              <a:t>5 unabhängige Security-Scanner in der CI, geschützter main-Branch</a:t>
+            </a:r>
+          </a:p>
+        </p:txBody>
+      </p:sp>
+      <p:sp>
+        <p:nvSpPr>
+          <p:cNvPr id="10" name="Rounded Rectangle 9"/>
+          <p:cNvSpPr/>
+          <p:nvPr/>
+        </p:nvSpPr>
+        <p:spPr>
+          <a:xfrm>
+            <a:off x="548640" y="4160520"/>
+            <a:ext cx="5349240" cy="1783080"/>
+          </a:xfrm>
+          <a:prstGeom prst="roundRect">
+            <a:avLst/>
+          </a:prstGeom>
+          <a:solidFill>
+            <a:srgbClr val="151E33"/>
+          </a:solidFill>
+          <a:ln w="12700">
+            <a:solidFill>
+              <a:srgbClr val="2A3652"/>
+            </a:solidFill>
+          </a:ln>
+          <a:effectLst/>
+        </p:spPr>
+        <p:style>
+          <a:lnRef idx="1">
+            <a:schemeClr val="accent1"/>
+          </a:lnRef>
+          <a:fillRef idx="3">
+            <a:schemeClr val="accent1"/>
+          </a:fillRef>
+          <a:effectRef idx="2">
+            <a:schemeClr val="accent1"/>
+          </a:effectRef>
+          <a:fontRef idx="minor">
+            <a:schemeClr val="lt1"/>
+          </a:fontRef>
+        </p:style>
+        <p:txBody>
+          <a:bodyPr rtlCol="0" anchor="ctr"/>
+          <a:lstStyle/>
+          <a:p>
+            <a:pPr algn="ctr"/>
+          </a:p>
+        </p:txBody>
+      </p:sp>
+      <p:sp>
+        <p:nvSpPr>
+          <p:cNvPr id="11" name="TextBox 10"/>
+          <p:cNvSpPr txBox="1"/>
+          <p:nvPr/>
+        </p:nvSpPr>
+        <p:spPr>
+          <a:xfrm>
+            <a:off x="841247" y="4361688"/>
+            <a:ext cx="4846320" cy="365760"/>
+          </a:xfrm>
+          <a:prstGeom prst="rect">
+            <a:avLst/>
+          </a:prstGeom>
+          <a:noFill/>
+        </p:spPr>
+        <p:txBody>
+          <a:bodyPr wrap="square" anchor="t" lIns="0" rIns="0" tIns="0" bIns="0">
+            <a:spAutoFit/>
+          </a:bodyPr>
+          <a:lstStyle/>
+          <a:p>
+            <a:pPr algn="l">
+              <a:lnSpc>
+                <a:spcPct val="100000"/>
+              </a:lnSpc>
+              <a:spcBef>
+                <a:spcPts val="0"/>
+              </a:spcBef>
+              <a:spcAft>
+                <a:spcPts val="600"/>
+              </a:spcAft>
+            </a:pPr>
+            <a:r>
+              <a:rPr sz="1600" b="1">
+                <a:solidFill>
+                  <a:srgbClr val="7C83FF"/>
+                </a:solidFill>
+                <a:latin typeface="Segoe UI"/>
+              </a:rPr>
+              <a:t>Reichweite</a:t>
+            </a:r>
+          </a:p>
+        </p:txBody>
+      </p:sp>
+      <p:sp>
+        <p:nvSpPr>
+          <p:cNvPr id="12" name="TextBox 11"/>
+          <p:cNvSpPr txBox="1"/>
+          <p:nvPr/>
+        </p:nvSpPr>
+        <p:spPr>
+          <a:xfrm>
+            <a:off x="841247" y="4818888"/>
+            <a:ext cx="4800600" cy="1005840"/>
+          </a:xfrm>
+          <a:prstGeom prst="rect">
+            <a:avLst/>
+          </a:prstGeom>
+          <a:noFill/>
+        </p:spPr>
+        <p:txBody>
+          <a:bodyPr wrap="square" anchor="t" lIns="0" rIns="0" tIns="0" bIns="0">
+            <a:spAutoFit/>
+          </a:bodyPr>
+          <a:lstStyle/>
+          <a:p>
+            <a:pPr algn="l">
+              <a:lnSpc>
+                <a:spcPct val="103000"/>
+              </a:lnSpc>
+              <a:spcBef>
+                <a:spcPts val="0"/>
+              </a:spcBef>
+              <a:spcAft>
+                <a:spcPts val="700"/>
+              </a:spcAft>
+            </a:pPr>
+            <a:r>
+              <a:rPr sz="1400" b="1">
+                <a:solidFill>
+                  <a:srgbClr val="7C83FF"/>
+                </a:solidFill>
+                <a:latin typeface="Segoe UI"/>
+              </a:rPr>
+              <a:t>▸  </a:t>
+            </a:r>
+            <a:r>
+              <a:rPr sz="1400" b="0">
+                <a:solidFill>
+                  <a:srgbClr val="F2F5FA"/>
+                </a:solidFill>
+                <a:latin typeface="Segoe UI"/>
+              </a:rPr>
+              <a:t>Zweisprachig DE/EN, offline- und proxy-fähig</a:t>
+            </a:r>
+          </a:p>
+          <a:p>
+            <a:pPr algn="l">
+              <a:lnSpc>
+                <a:spcPct val="103000"/>
+              </a:lnSpc>
+              <a:spcBef>
+                <a:spcPts val="0"/>
+              </a:spcBef>
+              <a:spcAft>
+                <a:spcPts val="700"/>
+              </a:spcAft>
+            </a:pPr>
+            <a:r>
+              <a:rPr sz="1400" b="1">
+                <a:solidFill>
+                  <a:srgbClr val="7C83FF"/>
+                </a:solidFill>
+                <a:latin typeface="Segoe UI"/>
+              </a:rPr>
+              <a:t>▸  </a:t>
+            </a:r>
+            <a:r>
+              <a:rPr sz="1400" b="0">
+                <a:solidFill>
+                  <a:srgbClr val="F2F5FA"/>
+                </a:solidFill>
+                <a:latin typeface="Segoe UI"/>
+              </a:rPr>
+              <a:t>Lesende API für Grafana, CMDB &amp; Co.</a:t>
+            </a:r>
+          </a:p>
+        </p:txBody>
+      </p:sp>
+      <p:sp>
+        <p:nvSpPr>
+          <p:cNvPr id="13" name="Rounded Rectangle 12"/>
+          <p:cNvSpPr/>
+          <p:nvPr/>
+        </p:nvSpPr>
+        <p:spPr>
+          <a:xfrm>
+            <a:off x="6309360" y="4160520"/>
+            <a:ext cx="5349240" cy="1783080"/>
+          </a:xfrm>
+          <a:prstGeom prst="roundRect">
+            <a:avLst/>
+          </a:prstGeom>
+          <a:solidFill>
+            <a:srgbClr val="151E33"/>
+          </a:solidFill>
+          <a:ln w="12700">
+            <a:solidFill>
+              <a:srgbClr val="2A3652"/>
+            </a:solidFill>
+          </a:ln>
+          <a:effectLst/>
+        </p:spPr>
+        <p:style>
+          <a:lnRef idx="1">
+            <a:schemeClr val="accent1"/>
+          </a:lnRef>
+          <a:fillRef idx="3">
+            <a:schemeClr val="accent1"/>
+          </a:fillRef>
+          <a:effectRef idx="2">
+            <a:schemeClr val="accent1"/>
+          </a:effectRef>
+          <a:fontRef idx="minor">
+            <a:schemeClr val="lt1"/>
+          </a:fontRef>
+        </p:style>
+        <p:txBody>
+          <a:bodyPr rtlCol="0" anchor="ctr"/>
+          <a:lstStyle/>
+          <a:p>
+            <a:pPr algn="ctr"/>
+          </a:p>
+        </p:txBody>
+      </p:sp>
+      <p:sp>
+        <p:nvSpPr>
+          <p:cNvPr id="14" name="TextBox 13"/>
+          <p:cNvSpPr txBox="1"/>
+          <p:nvPr/>
+        </p:nvSpPr>
+        <p:spPr>
+          <a:xfrm>
+            <a:off x="6601968" y="4361688"/>
+            <a:ext cx="4846320" cy="365760"/>
+          </a:xfrm>
+          <a:prstGeom prst="rect">
+            <a:avLst/>
+          </a:prstGeom>
+          <a:noFill/>
+        </p:spPr>
+        <p:txBody>
+          <a:bodyPr wrap="square" anchor="t" lIns="0" rIns="0" tIns="0" bIns="0">
+            <a:spAutoFit/>
+          </a:bodyPr>
+          <a:lstStyle/>
+          <a:p>
+            <a:pPr algn="l">
+              <a:lnSpc>
+                <a:spcPct val="100000"/>
+              </a:lnSpc>
+              <a:spcBef>
+                <a:spcPts val="0"/>
+              </a:spcBef>
+              <a:spcAft>
+                <a:spcPts val="600"/>
+              </a:spcAft>
+            </a:pPr>
+            <a:r>
+              <a:rPr sz="1600" b="1">
+                <a:solidFill>
+                  <a:srgbClr val="7C83FF"/>
+                </a:solidFill>
+                <a:latin typeface="Segoe UI"/>
+              </a:rPr>
+              <a:t>Pflege &amp; Reife</a:t>
+            </a:r>
+          </a:p>
+        </p:txBody>
+      </p:sp>
+      <p:sp>
+        <p:nvSpPr>
+          <p:cNvPr id="15" name="TextBox 14"/>
+          <p:cNvSpPr txBox="1"/>
+          <p:nvPr/>
+        </p:nvSpPr>
+        <p:spPr>
+          <a:xfrm>
+            <a:off x="6601968" y="4818888"/>
+            <a:ext cx="4800600" cy="1005840"/>
+          </a:xfrm>
+          <a:prstGeom prst="rect">
+            <a:avLst/>
+          </a:prstGeom>
+          <a:noFill/>
+        </p:spPr>
+        <p:txBody>
+          <a:bodyPr wrap="square" anchor="t" lIns="0" rIns="0" tIns="0" bIns="0">
+            <a:spAutoFit/>
+          </a:bodyPr>
+          <a:lstStyle/>
+          <a:p>
+            <a:pPr algn="l">
+              <a:lnSpc>
+                <a:spcPct val="103000"/>
+              </a:lnSpc>
+              <a:spcBef>
+                <a:spcPts val="0"/>
+              </a:spcBef>
+              <a:spcAft>
+                <a:spcPts val="700"/>
+              </a:spcAft>
+            </a:pPr>
+            <a:r>
+              <a:rPr sz="1400" b="1">
+                <a:solidFill>
+                  <a:srgbClr val="7C83FF"/>
+                </a:solidFill>
+                <a:latin typeface="Segoe UI"/>
+              </a:rPr>
+              <a:t>▸  </a:t>
+            </a:r>
+            <a:r>
+              <a:rPr sz="1400" b="0">
+                <a:solidFill>
+                  <a:srgbClr val="F2F5FA"/>
+                </a:solidFill>
+                <a:latin typeface="Segoe UI"/>
+              </a:rPr>
+              <a:t>Aktiv weiterentwickelt — über 100 Releases</a:t>
+            </a:r>
+          </a:p>
+          <a:p>
+            <a:pPr algn="l">
+              <a:lnSpc>
+                <a:spcPct val="103000"/>
+              </a:lnSpc>
+              <a:spcBef>
+                <a:spcPts val="0"/>
+              </a:spcBef>
+              <a:spcAft>
+                <a:spcPts val="700"/>
+              </a:spcAft>
+            </a:pPr>
+            <a:r>
+              <a:rPr sz="1400" b="1">
+                <a:solidFill>
+                  <a:srgbClr val="7C83FF"/>
+                </a:solidFill>
+                <a:latin typeface="Segoe UI"/>
+              </a:rPr>
+              <a:t>▸  </a:t>
+            </a:r>
+            <a:r>
+              <a:rPr sz="1400" b="0">
+                <a:solidFill>
+                  <a:srgbClr val="F2F5FA"/>
+                </a:solidFill>
+                <a:latin typeface="Segoe UI"/>
+              </a:rPr>
+              <a:t>Reviewer-Handbuch, Architektur-Doku, Smoke-Tests inklusive</a:t>
+            </a:r>
+          </a:p>
+        </p:txBody>
+      </p:sp>
+      <p:sp>
+        <p:nvSpPr>
+          <p:cNvPr id="16" name="TextBox 15"/>
+          <p:cNvSpPr txBox="1"/>
+          <p:nvPr/>
+        </p:nvSpPr>
+        <p:spPr>
+          <a:xfrm>
+            <a:off x="548640" y="6144768"/>
+            <a:ext cx="10972800" cy="457200"/>
+          </a:xfrm>
+          <a:prstGeom prst="rect">
+            <a:avLst/>
+          </a:prstGeom>
+          <a:noFill/>
+        </p:spPr>
+        <p:txBody>
+          <a:bodyPr wrap="square" anchor="t" lIns="0" rIns="0" tIns="0" bIns="0">
+            <a:spAutoFit/>
+          </a:bodyPr>
+          <a:lstStyle/>
+          <a:p>
+            <a:pPr algn="l">
+              <a:lnSpc>
+                <a:spcPct val="100000"/>
+              </a:lnSpc>
+              <a:spcBef>
+                <a:spcPts val="0"/>
+              </a:spcBef>
+              <a:spcAft>
+                <a:spcPts val="600"/>
+              </a:spcAft>
+            </a:pPr>
+            <a:r>
+              <a:rPr sz="1600" b="1">
+                <a:solidFill>
+                  <a:srgbClr val="34D399"/>
+                </a:solidFill>
+                <a:latin typeface="Segoe UI"/>
+              </a:rPr>
+              <a:t>Wenig Angriffsfläche. Kein Vendor-Lock-in. Sofort einsatzbereit.</a:t>
+            </a:r>
+          </a:p>
+        </p:txBody>
+      </p:sp>
+      <p:sp>
+        <p:nvSpPr>
+          <p:cNvPr id="17" name="Rectangle 16"/>
+          <p:cNvSpPr/>
+          <p:nvPr/>
+        </p:nvSpPr>
+        <p:spPr>
+          <a:xfrm>
+            <a:off x="0" y="6729984"/>
+            <a:ext cx="12191695" cy="128016"/>
+          </a:xfrm>
+          <a:prstGeom prst="rect">
+            <a:avLst/>
+          </a:prstGeom>
+          <a:solidFill>
+            <a:srgbClr val="7C83FF"/>
+          </a:solidFill>
+          <a:ln>
+            <a:noFill/>
+          </a:ln>
+          <a:effectLst/>
+        </p:spPr>
+        <p:style>
+          <a:lnRef idx="1">
+            <a:schemeClr val="accent1"/>
+          </a:lnRef>
+          <a:fillRef idx="3">
+            <a:schemeClr val="accent1"/>
+          </a:fillRef>
+          <a:effectRef idx="2">
+            <a:schemeClr val="accent1"/>
+          </a:effectRef>
+          <a:fontRef idx="minor">
+            <a:schemeClr val="lt1"/>
+          </a:fontRef>
+        </p:style>
+        <p:txBody>
+          <a:bodyPr rtlCol="0" anchor="ctr"/>
+          <a:lstStyle/>
+          <a:p>
+            <a:pPr algn="ctr"/>
+          </a:p>
+        </p:txBody>
+      </p:sp>
+      <p:sp>
+        <p:nvSpPr>
+          <p:cNvPr id="18" name="TextBox 17"/>
+          <p:cNvSpPr txBox="1"/>
+          <p:nvPr/>
+        </p:nvSpPr>
+        <p:spPr>
+          <a:xfrm>
+            <a:off x="10515600" y="6419088"/>
+            <a:ext cx="1554480" cy="274320"/>
+          </a:xfrm>
+          <a:prstGeom prst="rect">
+            <a:avLst/>
+          </a:prstGeom>
+          <a:noFill/>
+        </p:spPr>
+        <p:txBody>
+          <a:bodyPr wrap="square" anchor="t" lIns="0" rIns="0" tIns="0" bIns="0">
+            <a:spAutoFit/>
+          </a:bodyPr>
+          <a:lstStyle/>
+          <a:p>
+            <a:pPr algn="r">
+              <a:lnSpc>
+                <a:spcPct val="100000"/>
+              </a:lnSpc>
+              <a:spcBef>
+                <a:spcPts val="0"/>
+              </a:spcBef>
+              <a:spcAft>
+                <a:spcPts val="600"/>
+              </a:spcAft>
+            </a:pPr>
+            <a:r>
+              <a:rPr sz="1000" b="0">
+                <a:solidFill>
+                  <a:srgbClr val="93A0B5"/>
+                </a:solidFill>
+                <a:latin typeface="Segoe UI"/>
+              </a:rPr>
+              <a:t>9 / 10</a:t>
             </a:r>
           </a:p>
         </p:txBody>

</xml_diff>

<commit_message>
Fix: Folie 7 der Präsentation – Textüberlappungen behoben
- Bildunterschriften: Titel + Untertitel laufen jetzt als EIN fließender
  Textblock (zwei Absätze) statt fester Positionen – kein Überlappen mehr,
  auch wenn ein Titel umbricht. Mittleren Titel gekürzt
  („Rollen, AD & Sichtbarkeit").
- „Außerdem"-Zeile gekürzt und höher gesetzt, sodass sie einzeilig bleibt und
  nicht mehr in die Fußzeile läuft.

Co-Authored-By: Claude Opus 4.8 <noreply@anthropic.com>
</commit_message>
<xml_diff>
--- a/docs/praesentation/VMware-Kapazitaetsplanung.pptx
+++ b/docs/praesentation/VMware-Kapazitaetsplanung.pptx
@@ -7761,8 +7761,8 @@
         </p:nvSpPr>
         <p:spPr>
           <a:xfrm>
-            <a:off x="548640" y="1600200"/>
-            <a:ext cx="3474720" cy="3154680"/>
+            <a:off x="548640" y="1554480"/>
+            <a:ext cx="3474720" cy="3108960"/>
           </a:xfrm>
           <a:prstGeom prst="roundRect">
             <a:avLst/>
@@ -7815,7 +7815,7 @@
         </p:blipFill>
         <p:spPr>
           <a:xfrm>
-            <a:off x="658368" y="2315852"/>
+            <a:off x="658368" y="2247272"/>
             <a:ext cx="3255264" cy="1723375"/>
           </a:xfrm>
           <a:prstGeom prst="rect">
@@ -7836,8 +7836,8 @@
         </p:nvSpPr>
         <p:spPr>
           <a:xfrm>
-            <a:off x="594360" y="4882896"/>
-            <a:ext cx="3429000" cy="365760"/>
+            <a:off x="594360" y="4809744"/>
+            <a:ext cx="3401568" cy="960120"/>
           </a:xfrm>
           <a:prstGeom prst="rect">
             <a:avLst/>
@@ -7852,13 +7852,13 @@
           <a:p>
             <a:pPr algn="l">
               <a:lnSpc>
-                <a:spcPct val="100000"/>
-              </a:lnSpc>
-              <a:spcBef>
-                <a:spcPts val="0"/>
-              </a:spcBef>
-              <a:spcAft>
-                <a:spcPts val="600"/>
+                <a:spcPct val="102000"/>
+              </a:lnSpc>
+              <a:spcBef>
+                <a:spcPts val="0"/>
+              </a:spcBef>
+              <a:spcAft>
+                <a:spcPts val="300"/>
               </a:spcAft>
             </a:pPr>
             <a:r>
@@ -7871,29 +7871,6 @@
               <a:t>VLAN-/Netzwerk-Suche</a:t>
             </a:r>
           </a:p>
-        </p:txBody>
-      </p:sp>
-      <p:sp>
-        <p:nvSpPr>
-          <p:cNvPr id="7" name="TextBox 6"/>
-          <p:cNvSpPr txBox="1"/>
-          <p:nvPr/>
-        </p:nvSpPr>
-        <p:spPr>
-          <a:xfrm>
-            <a:off x="594360" y="5230368"/>
-            <a:ext cx="3429000" cy="640080"/>
-          </a:xfrm>
-          <a:prstGeom prst="rect">
-            <a:avLst/>
-          </a:prstGeom>
-          <a:noFill/>
-        </p:spPr>
-        <p:txBody>
-          <a:bodyPr wrap="square" anchor="t" lIns="0" rIns="0" tIns="0" bIns="0">
-            <a:spAutoFit/>
-          </a:bodyPr>
-          <a:lstStyle/>
           <a:p>
             <a:pPr algn="l">
               <a:lnSpc>
@@ -7903,7 +7880,7 @@
                 <a:spcPts val="0"/>
               </a:spcBef>
               <a:spcAft>
-                <a:spcPts val="600"/>
+                <a:spcPts val="300"/>
               </a:spcAft>
             </a:pPr>
             <a:r>
@@ -7920,14 +7897,14 @@
       </p:sp>
       <p:sp>
         <p:nvSpPr>
-          <p:cNvPr id="8" name="Rounded Rectangle 7"/>
+          <p:cNvPr id="7" name="Rounded Rectangle 6"/>
           <p:cNvSpPr/>
           <p:nvPr/>
         </p:nvSpPr>
         <p:spPr>
           <a:xfrm>
-            <a:off x="4352544" y="1600200"/>
-            <a:ext cx="3474720" cy="3154680"/>
+            <a:off x="4352544" y="1554480"/>
+            <a:ext cx="3474720" cy="3108960"/>
           </a:xfrm>
           <a:prstGeom prst="roundRect">
             <a:avLst/>
@@ -7966,7 +7943,7 @@
       </p:sp>
       <p:pic>
         <p:nvPicPr>
-          <p:cNvPr id="9" name="Picture 8" descr="08_verwaltung.png"/>
+          <p:cNvPr id="8" name="Picture 7" descr="08_verwaltung.png"/>
           <p:cNvPicPr>
             <a:picLocks noChangeAspect="1"/>
           </p:cNvPicPr>
@@ -7980,7 +7957,7 @@
         </p:blipFill>
         <p:spPr>
           <a:xfrm>
-            <a:off x="4462272" y="2267981"/>
+            <a:off x="4462272" y="2199401"/>
             <a:ext cx="3255264" cy="1819118"/>
           </a:xfrm>
           <a:prstGeom prst="rect">
@@ -7995,14 +7972,14 @@
       </p:pic>
       <p:sp>
         <p:nvSpPr>
-          <p:cNvPr id="10" name="TextBox 9"/>
+          <p:cNvPr id="9" name="TextBox 8"/>
           <p:cNvSpPr txBox="1"/>
           <p:nvPr/>
         </p:nvSpPr>
         <p:spPr>
           <a:xfrm>
-            <a:off x="4398264" y="4882896"/>
-            <a:ext cx="3429000" cy="365760"/>
+            <a:off x="4398264" y="4809744"/>
+            <a:ext cx="3401568" cy="960120"/>
           </a:xfrm>
           <a:prstGeom prst="rect">
             <a:avLst/>
@@ -8017,13 +7994,13 @@
           <a:p>
             <a:pPr algn="l">
               <a:lnSpc>
-                <a:spcPct val="100000"/>
-              </a:lnSpc>
-              <a:spcBef>
-                <a:spcPts val="0"/>
-              </a:spcBef>
-              <a:spcAft>
-                <a:spcPts val="600"/>
+                <a:spcPct val="102000"/>
+              </a:lnSpc>
+              <a:spcBef>
+                <a:spcPts val="0"/>
+              </a:spcBef>
+              <a:spcAft>
+                <a:spcPts val="300"/>
               </a:spcAft>
             </a:pPr>
             <a:r>
@@ -8033,32 +8010,9 @@
                 </a:solidFill>
                 <a:latin typeface="Segoe UI"/>
               </a:rPr>
-              <a:t>Rollen, AD-Gruppen &amp; Sichtbarkeit</a:t>
-            </a:r>
-          </a:p>
-        </p:txBody>
-      </p:sp>
-      <p:sp>
-        <p:nvSpPr>
-          <p:cNvPr id="11" name="TextBox 10"/>
-          <p:cNvSpPr txBox="1"/>
-          <p:nvPr/>
-        </p:nvSpPr>
-        <p:spPr>
-          <a:xfrm>
-            <a:off x="4398264" y="5230368"/>
-            <a:ext cx="3429000" cy="640080"/>
-          </a:xfrm>
-          <a:prstGeom prst="rect">
-            <a:avLst/>
-          </a:prstGeom>
-          <a:noFill/>
-        </p:spPr>
-        <p:txBody>
-          <a:bodyPr wrap="square" anchor="t" lIns="0" rIns="0" tIns="0" bIns="0">
-            <a:spAutoFit/>
-          </a:bodyPr>
-          <a:lstStyle/>
+              <a:t>Rollen, AD &amp; Sichtbarkeit</a:t>
+            </a:r>
+          </a:p>
           <a:p>
             <a:pPr algn="l">
               <a:lnSpc>
@@ -8068,7 +8022,7 @@
                 <a:spcPts val="0"/>
               </a:spcBef>
               <a:spcAft>
-                <a:spcPts val="600"/>
+                <a:spcPts val="300"/>
               </a:spcAft>
             </a:pPr>
             <a:r>
@@ -8085,14 +8039,14 @@
       </p:sp>
       <p:sp>
         <p:nvSpPr>
-          <p:cNvPr id="12" name="Rounded Rectangle 11"/>
+          <p:cNvPr id="10" name="Rounded Rectangle 9"/>
           <p:cNvSpPr/>
           <p:nvPr/>
         </p:nvSpPr>
         <p:spPr>
           <a:xfrm>
-            <a:off x="8156448" y="1600200"/>
-            <a:ext cx="3474720" cy="3154680"/>
+            <a:off x="8156448" y="1554480"/>
+            <a:ext cx="3474720" cy="3108960"/>
           </a:xfrm>
           <a:prstGeom prst="roundRect">
             <a:avLst/>
@@ -8131,7 +8085,7 @@
       </p:sp>
       <p:pic>
         <p:nvPicPr>
-          <p:cNvPr id="13" name="Picture 12" descr="09_apidocs.png"/>
+          <p:cNvPr id="11" name="Picture 10" descr="09_apidocs.png"/>
           <p:cNvPicPr>
             <a:picLocks noChangeAspect="1"/>
           </p:cNvPicPr>
@@ -8145,7 +8099,7 @@
         </p:blipFill>
         <p:spPr>
           <a:xfrm>
-            <a:off x="8266175" y="2148302"/>
+            <a:off x="8266175" y="2079722"/>
             <a:ext cx="3255264" cy="2058475"/>
           </a:xfrm>
           <a:prstGeom prst="rect">
@@ -8160,14 +8114,14 @@
       </p:pic>
       <p:sp>
         <p:nvSpPr>
-          <p:cNvPr id="14" name="TextBox 13"/>
+          <p:cNvPr id="12" name="TextBox 11"/>
           <p:cNvSpPr txBox="1"/>
           <p:nvPr/>
         </p:nvSpPr>
         <p:spPr>
           <a:xfrm>
-            <a:off x="8202168" y="4882896"/>
-            <a:ext cx="3429000" cy="365760"/>
+            <a:off x="8202168" y="4809744"/>
+            <a:ext cx="3401568" cy="960120"/>
           </a:xfrm>
           <a:prstGeom prst="rect">
             <a:avLst/>
@@ -8182,13 +8136,13 @@
           <a:p>
             <a:pPr algn="l">
               <a:lnSpc>
-                <a:spcPct val="100000"/>
-              </a:lnSpc>
-              <a:spcBef>
-                <a:spcPts val="0"/>
-              </a:spcBef>
-              <a:spcAft>
-                <a:spcPts val="600"/>
+                <a:spcPct val="102000"/>
+              </a:lnSpc>
+              <a:spcBef>
+                <a:spcPts val="0"/>
+              </a:spcBef>
+              <a:spcAft>
+                <a:spcPts val="300"/>
               </a:spcAft>
             </a:pPr>
             <a:r>
@@ -8201,18 +8155,40 @@
               <a:t>Eingebaute REST-API</a:t>
             </a:r>
           </a:p>
-        </p:txBody>
-      </p:sp>
-      <p:sp>
-        <p:nvSpPr>
-          <p:cNvPr id="15" name="TextBox 14"/>
+          <a:p>
+            <a:pPr algn="l">
+              <a:lnSpc>
+                <a:spcPct val="102000"/>
+              </a:lnSpc>
+              <a:spcBef>
+                <a:spcPts val="0"/>
+              </a:spcBef>
+              <a:spcAft>
+                <a:spcPts val="300"/>
+              </a:spcAft>
+            </a:pPr>
+            <a:r>
+              <a:rPr sz="1150" b="0">
+                <a:solidFill>
+                  <a:srgbClr val="93A0B5"/>
+                </a:solidFill>
+                <a:latin typeface="Segoe UI"/>
+              </a:rPr>
+              <a:t>für Grafana, CMDB &amp; Automatisierung</a:t>
+            </a:r>
+          </a:p>
+        </p:txBody>
+      </p:sp>
+      <p:sp>
+        <p:nvSpPr>
+          <p:cNvPr id="13" name="TextBox 12"/>
           <p:cNvSpPr txBox="1"/>
           <p:nvPr/>
         </p:nvSpPr>
         <p:spPr>
           <a:xfrm>
-            <a:off x="8202168" y="5230368"/>
-            <a:ext cx="3429000" cy="640080"/>
+            <a:off x="548640" y="6035040"/>
+            <a:ext cx="11109960" cy="457200"/>
           </a:xfrm>
           <a:prstGeom prst="rect">
             <a:avLst/>
@@ -8227,7 +8203,7 @@
           <a:p>
             <a:pPr algn="l">
               <a:lnSpc>
-                <a:spcPct val="102000"/>
+                <a:spcPct val="105000"/>
               </a:lnSpc>
               <a:spcBef>
                 <a:spcPts val="0"/>
@@ -8237,74 +8213,29 @@
               </a:spcAft>
             </a:pPr>
             <a:r>
-              <a:rPr sz="1150" b="0">
+              <a:rPr sz="1200" b="1">
+                <a:solidFill>
+                  <a:srgbClr val="7C83FF"/>
+                </a:solidFill>
+                <a:latin typeface="Segoe UI"/>
+              </a:rPr>
+              <a:t>Außerdem: </a:t>
+            </a:r>
+            <a:r>
+              <a:rPr sz="1200" b="0">
                 <a:solidFill>
                   <a:srgbClr val="93A0B5"/>
                 </a:solidFill>
                 <a:latin typeface="Segoe UI"/>
               </a:rPr>
-              <a:t>für Grafana, CMDB &amp; Automatisierung</a:t>
-            </a:r>
-          </a:p>
-        </p:txBody>
-      </p:sp>
-      <p:sp>
-        <p:nvSpPr>
-          <p:cNvPr id="16" name="TextBox 15"/>
-          <p:cNvSpPr txBox="1"/>
-          <p:nvPr/>
-        </p:nvSpPr>
-        <p:spPr>
-          <a:xfrm>
-            <a:off x="548640" y="6144768"/>
-            <a:ext cx="11064240" cy="457200"/>
-          </a:xfrm>
-          <a:prstGeom prst="rect">
-            <a:avLst/>
-          </a:prstGeom>
-          <a:noFill/>
-        </p:spPr>
-        <p:txBody>
-          <a:bodyPr wrap="square" anchor="t" lIns="0" rIns="0" tIns="0" bIns="0">
-            <a:spAutoFit/>
-          </a:bodyPr>
-          <a:lstStyle/>
-          <a:p>
-            <a:pPr algn="l">
-              <a:lnSpc>
-                <a:spcPct val="105000"/>
-              </a:lnSpc>
-              <a:spcBef>
-                <a:spcPts val="0"/>
-              </a:spcBef>
-              <a:spcAft>
-                <a:spcPts val="600"/>
-              </a:spcAft>
-            </a:pPr>
-            <a:r>
-              <a:rPr sz="1250" b="1">
-                <a:solidFill>
-                  <a:srgbClr val="7C83FF"/>
-                </a:solidFill>
-                <a:latin typeface="Segoe UI"/>
-              </a:rPr>
-              <a:t>Außerdem: </a:t>
-            </a:r>
-            <a:r>
-              <a:rPr sz="1250" b="0">
-                <a:solidFill>
-                  <a:srgbClr val="93A0B5"/>
-                </a:solidFill>
-                <a:latin typeface="Segoe UI"/>
-              </a:rPr>
-              <a:t>Hell-/Dunkel-Modus · SFTP-Backup · Mail-Benachrichtigungen &amp; Erinnerungen · CSV-Import/Export · Auto-Freigabe · Reviewer-Handbuch · Ankündigungen · konfigurierbare Zeitzone · seitenweises Blättern</a:t>
-            </a:r>
-          </a:p>
-        </p:txBody>
-      </p:sp>
-      <p:sp>
-        <p:nvSpPr>
-          <p:cNvPr id="17" name="Rectangle 16"/>
+              <a:t>Hell-/Dunkel-Modus · SFTP-Backup · Mail &amp; Erinnerungen · CSV-Export · Auto-Freigabe · Reviewer-Handbuch · Zeitzone · Blättern</a:t>
+            </a:r>
+          </a:p>
+        </p:txBody>
+      </p:sp>
+      <p:sp>
+        <p:nvSpPr>
+          <p:cNvPr id="14" name="Rectangle 13"/>
           <p:cNvSpPr/>
           <p:nvPr/>
         </p:nvSpPr>
@@ -8348,7 +8279,7 @@
       </p:sp>
       <p:sp>
         <p:nvSpPr>
-          <p:cNvPr id="18" name="TextBox 17"/>
+          <p:cNvPr id="15" name="TextBox 14"/>
           <p:cNvSpPr txBox="1"/>
           <p:nvPr/>
         </p:nvSpPr>
@@ -8393,7 +8324,7 @@
       </p:sp>
       <p:sp>
         <p:nvSpPr>
-          <p:cNvPr id="19" name="TextBox 18"/>
+          <p:cNvPr id="16" name="TextBox 15"/>
           <p:cNvSpPr txBox="1"/>
           <p:nvPr/>
         </p:nvSpPr>

</xml_diff>

<commit_message>
Präsentation: KI-Urheberschaft dezent hervorgehoben
An drei passenden Stellen (in Akzentfarbe) ergänzt, dass die Anwendung mit
einer KI (Claude · Anthropic) entwickelt wurde:
- Titelfolie: Fußzeile „Von einer KI (Claude · Anthropic) geschrieben"
- Folie 8 „Das Projekt in Zahlen": „…vollständig mit einer KI (Claude) geschrieben"
- Folie 9 „Fazit": Box „Entwicklung & Reife" nennt die KI-Entwicklung als
  Effizienz-/Tempo-Argument

Co-Authored-By: Claude Opus 4.8 <noreply@anthropic.com>
</commit_message>
<xml_diff>
--- a/docs/praesentation/VMware-Kapazitaetsplanung.pptx
+++ b/docs/praesentation/VMware-Kapazitaetsplanung.pptx
@@ -3384,13 +3384,22 @@
               </a:spcAft>
             </a:pPr>
             <a:r>
+              <a:rPr sz="1350" b="1">
+                <a:solidFill>
+                  <a:srgbClr val="7C83FF"/>
+                </a:solidFill>
+                <a:latin typeface="Segoe UI"/>
+              </a:rPr>
+              <a:t>Von einer KI (Claude · Anthropic) geschrieben</a:t>
+            </a:r>
+            <a:r>
               <a:rPr sz="1350" b="0">
                 <a:solidFill>
                   <a:srgbClr val="93A0B5"/>
                 </a:solidFill>
                 <a:latin typeface="Segoe UI"/>
               </a:rPr>
-              <a:t>Eine Python-Datei · keine Fremd-Abhängigkeiten · zweisprachig DE/EN · läuft auf jedem RHEL-Host · über 100 Releases</a:t>
+              <a:t>  ·  eine Python-Datei ohne Fremd-Abhängigkeiten · zweisprachig DE/EN · läuft auf jedem RHEL-Host</a:t>
             </a:r>
           </a:p>
         </p:txBody>
@@ -8492,7 +8501,7 @@
         <p:spPr>
           <a:xfrm>
             <a:off x="548640" y="1737360"/>
-            <a:ext cx="10972800" cy="457200"/>
+            <a:ext cx="11064240" cy="457200"/>
           </a:xfrm>
           <a:prstGeom prst="rect">
             <a:avLst/>
@@ -8523,7 +8532,16 @@
                 </a:solidFill>
                 <a:latin typeface="Segoe UI"/>
               </a:rPr>
-              <a:t>Von der ersten Zeile bis heute — in rund zwei Wochen aktiver Entwicklung.</a:t>
+              <a:t>In rund zwei Wochen entstanden — </a:t>
+            </a:r>
+            <a:r>
+              <a:rPr sz="1450" b="1">
+                <a:solidFill>
+                  <a:srgbClr val="7C83FF"/>
+                </a:solidFill>
+                <a:latin typeface="Segoe UI"/>
+              </a:rPr>
+              <a:t>vollständig mit einer KI (Claude) geschrieben.</a:t>
             </a:r>
           </a:p>
         </p:txBody>
@@ -10480,7 +10498,7 @@
                 </a:solidFill>
                 <a:latin typeface="Segoe UI"/>
               </a:rPr>
-              <a:t>Pflege &amp; Reife</a:t>
+              <a:t>Entwicklung &amp; Reife</a:t>
             </a:r>
           </a:p>
         </p:txBody>
@@ -10534,7 +10552,7 @@
                 </a:solidFill>
                 <a:latin typeface="Segoe UI"/>
               </a:rPr>
-              <a:t>Aktiv weiterentwickelt — über 100 Releases</a:t>
+              <a:t>Mit einer KI (Claude · Anthropic) entwickelt — hohes Tempo, konsequente Tests</a:t>
             </a:r>
           </a:p>
           <a:p>
@@ -10565,7 +10583,7 @@
                 </a:solidFill>
                 <a:latin typeface="Segoe UI"/>
               </a:rPr>
-              <a:t>Reviewer-Handbuch, Architektur-Doku, Smoke-Tests inklusive</a:t>
+              <a:t>Über 100 Releases, Reviewer-Handbuch, Architektur-Doku inklusive</a:t>
             </a:r>
           </a:p>
         </p:txBody>

</xml_diff>

<commit_message>
Präsentation: anklickbaren Live-Demo-Link ergänzt
- Titelfolie: grüne Zeile „▶ Live-Demo zum Anklicken: marcobockelbrink.github.io/vmware"
  als echter Hyperlink.
- Fazit (Folie 9): Schluss-Zeile in einen Live-Demo-Call-to-Action verwandelt
  („▶ Jetzt live ausprobieren: … · sofort einsatzbereit."), ebenfalls verlinkt.
- Neuer linkline()-Helfer für echte, klickbare Hyperlinks in den Folien.

Co-Authored-By: Claude Opus 4.8 <noreply@anthropic.com>
</commit_message>
<xml_diff>
--- a/docs/praesentation/VMware-Kapazitaetsplanung.pptx
+++ b/docs/praesentation/VMware-Kapazitaetsplanung.pptx
@@ -3269,7 +3269,7 @@
         </p:nvSpPr>
         <p:spPr>
           <a:xfrm>
-            <a:off x="822960" y="4160520"/>
+            <a:off x="822960" y="3931920"/>
             <a:ext cx="9875520" cy="914400"/>
           </a:xfrm>
           <a:prstGeom prst="rect">
@@ -3308,13 +3308,58 @@
       </p:sp>
       <p:sp>
         <p:nvSpPr>
-          <p:cNvPr id="6" name="Rectangle 5"/>
+          <p:cNvPr id="6" name="TextBox 5"/>
+          <p:cNvSpPr txBox="1"/>
+          <p:nvPr/>
+        </p:nvSpPr>
+        <p:spPr>
+          <a:xfrm>
+            <a:off x="822960" y="4754880"/>
+            <a:ext cx="10515600" cy="365760"/>
+          </a:xfrm>
+          <a:prstGeom prst="rect">
+            <a:avLst/>
+          </a:prstGeom>
+          <a:noFill/>
+        </p:spPr>
+        <p:txBody>
+          <a:bodyPr wrap="square" lIns="0" rIns="0" tIns="0" bIns="0">
+            <a:spAutoFit/>
+          </a:bodyPr>
+          <a:lstStyle/>
+          <a:p>
+            <a:pPr algn="l"/>
+            <a:r>
+              <a:rPr sz="1500" b="1">
+                <a:solidFill>
+                  <a:srgbClr val="34D399"/>
+                </a:solidFill>
+                <a:latin typeface="Segoe UI"/>
+              </a:rPr>
+              <a:t>▶ Live-Demo zum Anklicken:  </a:t>
+            </a:r>
+            <a:r>
+              <a:rPr sz="1500" b="1">
+                <a:solidFill>
+                  <a:srgbClr val="34D399"/>
+                </a:solidFill>
+                <a:latin typeface="Segoe UI"/>
+                <a:hlinkClick r:id="rId2"/>
+              </a:rPr>
+              <a:t>marcobockelbrink.github.io/vmware</a:t>
+            </a:r>
+          </a:p>
+        </p:txBody>
+      </p:sp>
+      <p:sp>
+        <p:nvSpPr>
+          <p:cNvPr id="7" name="Rectangle 6"/>
           <p:cNvSpPr/>
           <p:nvPr/>
         </p:nvSpPr>
         <p:spPr>
           <a:xfrm>
-            <a:off x="841248" y="5257800"/>
+            <a:off x="841248" y="5285232"/>
             <a:ext cx="5852160" cy="18288"/>
           </a:xfrm>
           <a:prstGeom prst="rect">
@@ -3352,13 +3397,13 @@
       </p:sp>
       <p:sp>
         <p:nvSpPr>
-          <p:cNvPr id="7" name="TextBox 6"/>
+          <p:cNvPr id="8" name="TextBox 7"/>
           <p:cNvSpPr txBox="1"/>
           <p:nvPr/>
         </p:nvSpPr>
         <p:spPr>
           <a:xfrm>
-            <a:off x="822960" y="5440680"/>
+            <a:off x="822960" y="5468112"/>
             <a:ext cx="10789920" cy="731520"/>
           </a:xfrm>
           <a:prstGeom prst="rect">
@@ -3406,7 +3451,7 @@
       </p:sp>
       <p:sp>
         <p:nvSpPr>
-          <p:cNvPr id="8" name="Rectangle 7"/>
+          <p:cNvPr id="9" name="Rectangle 8"/>
           <p:cNvSpPr/>
           <p:nvPr/>
         </p:nvSpPr>
@@ -3450,7 +3495,7 @@
       </p:sp>
       <p:sp>
         <p:nvSpPr>
-          <p:cNvPr id="9" name="TextBox 8"/>
+          <p:cNvPr id="10" name="TextBox 9"/>
           <p:cNvSpPr txBox="1"/>
           <p:nvPr/>
         </p:nvSpPr>
@@ -3495,7 +3540,7 @@
       </p:sp>
       <p:sp>
         <p:nvSpPr>
-          <p:cNvPr id="10" name="TextBox 9"/>
+          <p:cNvPr id="11" name="TextBox 10"/>
           <p:cNvSpPr txBox="1"/>
           <p:nvPr/>
         </p:nvSpPr>
@@ -10597,7 +10642,7 @@
         <p:spPr>
           <a:xfrm>
             <a:off x="548640" y="6144768"/>
-            <a:ext cx="10972800" cy="457200"/>
+            <a:ext cx="11064240" cy="457200"/>
           </a:xfrm>
           <a:prstGeom prst="rect">
             <a:avLst/>
@@ -10605,22 +10650,12 @@
           <a:noFill/>
         </p:spPr>
         <p:txBody>
-          <a:bodyPr wrap="square" anchor="t" lIns="0" rIns="0" tIns="0" bIns="0">
+          <a:bodyPr wrap="square" lIns="0" rIns="0" tIns="0" bIns="0">
             <a:spAutoFit/>
           </a:bodyPr>
           <a:lstStyle/>
           <a:p>
-            <a:pPr algn="l">
-              <a:lnSpc>
-                <a:spcPct val="100000"/>
-              </a:lnSpc>
-              <a:spcBef>
-                <a:spcPts val="0"/>
-              </a:spcBef>
-              <a:spcAft>
-                <a:spcPts val="600"/>
-              </a:spcAft>
-            </a:pPr>
+            <a:pPr algn="l"/>
             <a:r>
               <a:rPr sz="1600" b="1">
                 <a:solidFill>
@@ -10628,7 +10663,26 @@
                 </a:solidFill>
                 <a:latin typeface="Segoe UI"/>
               </a:rPr>
-              <a:t>Wenig Angriffsfläche. Kein Vendor-Lock-in. Sofort einsatzbereit.</a:t>
+              <a:t>▶ Jetzt live ausprobieren:  </a:t>
+            </a:r>
+            <a:r>
+              <a:rPr sz="1600" b="1">
+                <a:solidFill>
+                  <a:srgbClr val="34D399"/>
+                </a:solidFill>
+                <a:latin typeface="Segoe UI"/>
+                <a:hlinkClick r:id="rId2"/>
+              </a:rPr>
+              <a:t>marcobockelbrink.github.io/vmware</a:t>
+            </a:r>
+            <a:r>
+              <a:rPr sz="1600" b="0">
+                <a:solidFill>
+                  <a:srgbClr val="93A0B5"/>
+                </a:solidFill>
+                <a:latin typeface="Segoe UI"/>
+              </a:rPr>
+              <a:t>   ·  sofort einsatzbereit.</a:t>
             </a:r>
           </a:p>
         </p:txBody>

</xml_diff>